<commit_message>
수업 준비 : js-dom / css-media-query
</commit_message>
<xml_diff>
--- a/material/[SeSAC_YDP_6] 04_5_Javascript_표준객체,DOM.pptx
+++ b/material/[SeSAC_YDP_6] 04_5_Javascript_표준객체,DOM.pptx
@@ -248,7 +248,7 @@
           <a:p>
             <a:fld id="{2EF3F159-7250-4DD4-91C2-13B35D56E1AF}" type="datetimeFigureOut">
               <a:rPr lang="ko-KR" altLang="en-US" smtClean="0"/>
-              <a:t>2024-05-31</a:t>
+              <a:t>2024-06-03</a:t>
             </a:fld>
             <a:endParaRPr lang="ko-KR" altLang="en-US"/>
           </a:p>
@@ -8330,7 +8330,7 @@
           <a:p>
             <a:fld id="{0E19CB95-6D28-40F1-9DA3-1BAC5D4B5B4F}" type="datetime6">
               <a:rPr lang="ko-KR" altLang="en-US" smtClean="0"/>
-              <a:t>2024년 5월</a:t>
+              <a:t>2024년 6월</a:t>
             </a:fld>
             <a:endParaRPr lang="ko-KR" altLang="en-US"/>
           </a:p>
@@ -8460,7 +8460,7 @@
           <p:nvPr userDrawn="1"/>
         </p:nvPicPr>
         <p:blipFill>
-          <a:blip r:embed="rId2">
+          <a:blip r:embed="rId2" cstate="hqprint">
             <a:alphaModFix amt="20000"/>
             <a:extLst>
               <a:ext uri="{28A0092B-C50C-407E-A947-70E740481C1C}">
@@ -8710,7 +8710,7 @@
           <a:p>
             <a:fld id="{C4A39A32-5728-48B8-9F9C-437D214CCAF1}" type="datetime6">
               <a:rPr lang="ko-KR" altLang="en-US" smtClean="0"/>
-              <a:t>2024년 5월</a:t>
+              <a:t>2024년 6월</a:t>
             </a:fld>
             <a:endParaRPr lang="ko-KR" altLang="en-US"/>
           </a:p>
@@ -8912,7 +8912,7 @@
           <a:p>
             <a:fld id="{3BECC8BA-EBCB-4BF9-8E87-970CE0138376}" type="datetime6">
               <a:rPr lang="ko-KR" altLang="en-US" smtClean="0"/>
-              <a:t>2024년 5월</a:t>
+              <a:t>2024년 6월</a:t>
             </a:fld>
             <a:endParaRPr lang="ko-KR" altLang="en-US"/>
           </a:p>
@@ -9120,7 +9120,7 @@
           <a:p>
             <a:fld id="{7869FA6E-4699-4AC6-B2CB-4E60A58ED7A8}" type="datetime6">
               <a:rPr lang="ko-KR" altLang="en-US" smtClean="0"/>
-              <a:t>2024년 5월</a:t>
+              <a:t>2024년 6월</a:t>
             </a:fld>
             <a:endParaRPr lang="ko-KR" altLang="en-US"/>
           </a:p>
@@ -9233,7 +9233,7 @@
           <a:p>
             <a:fld id="{0E19CB95-6D28-40F1-9DA3-1BAC5D4B5B4F}" type="datetime6">
               <a:rPr lang="ko-KR" altLang="en-US" smtClean="0"/>
-              <a:t>2024년 5월</a:t>
+              <a:t>2024년 6월</a:t>
             </a:fld>
             <a:endParaRPr lang="ko-KR" altLang="en-US"/>
           </a:p>
@@ -9495,7 +9495,7 @@
           <a:p>
             <a:fld id="{3C9CE3CE-253F-4F9D-BA15-C226C8D8501E}" type="datetime6">
               <a:rPr lang="ko-KR" altLang="en-US" smtClean="0"/>
-              <a:t>2024년 5월</a:t>
+              <a:t>2024년 6월</a:t>
             </a:fld>
             <a:endParaRPr lang="ko-KR" altLang="en-US"/>
           </a:p>
@@ -9812,7 +9812,7 @@
           <a:p>
             <a:fld id="{BE5A7087-D460-46DD-B430-F8D9B9677D08}" type="datetime6">
               <a:rPr lang="ko-KR" altLang="en-US" smtClean="0"/>
-              <a:t>2024년 5월</a:t>
+              <a:t>2024년 6월</a:t>
             </a:fld>
             <a:endParaRPr lang="ko-KR" altLang="en-US"/>
           </a:p>
@@ -10081,7 +10081,7 @@
           <a:p>
             <a:fld id="{0581BA25-D675-4234-A003-8449BDEEF18E}" type="datetime6">
               <a:rPr lang="ko-KR" altLang="en-US" smtClean="0"/>
-              <a:t>2024년 5월</a:t>
+              <a:t>2024년 6월</a:t>
             </a:fld>
             <a:endParaRPr lang="ko-KR" altLang="en-US"/>
           </a:p>
@@ -10497,7 +10497,7 @@
           <a:p>
             <a:fld id="{26155C29-A87F-46F0-A24C-6C9F0A4BF6AA}" type="datetime6">
               <a:rPr lang="ko-KR" altLang="en-US" smtClean="0"/>
-              <a:t>2024년 5월</a:t>
+              <a:t>2024년 6월</a:t>
             </a:fld>
             <a:endParaRPr lang="ko-KR" altLang="en-US"/>
           </a:p>
@@ -10642,7 +10642,7 @@
           <a:p>
             <a:fld id="{DD2EDD62-8757-43DB-BAE0-460422B548EA}" type="datetime6">
               <a:rPr lang="ko-KR" altLang="en-US" smtClean="0"/>
-              <a:t>2024년 5월</a:t>
+              <a:t>2024년 6월</a:t>
             </a:fld>
             <a:endParaRPr lang="ko-KR" altLang="en-US"/>
           </a:p>
@@ -10755,7 +10755,7 @@
           <a:p>
             <a:fld id="{DC6A871B-4800-495F-AC75-93D44C7DEBA5}" type="datetime6">
               <a:rPr lang="ko-KR" altLang="en-US" smtClean="0"/>
-              <a:t>2024년 5월</a:t>
+              <a:t>2024년 6월</a:t>
             </a:fld>
             <a:endParaRPr lang="ko-KR" altLang="en-US"/>
           </a:p>
@@ -11066,7 +11066,7 @@
           <a:p>
             <a:fld id="{59605888-30A6-49BB-95E2-DEAE4E5B09E9}" type="datetime6">
               <a:rPr lang="ko-KR" altLang="en-US" smtClean="0"/>
-              <a:t>2024년 5월</a:t>
+              <a:t>2024년 6월</a:t>
             </a:fld>
             <a:endParaRPr lang="ko-KR" altLang="en-US"/>
           </a:p>
@@ -11307,7 +11307,7 @@
           <a:p>
             <a:fld id="{8691C14A-5735-4A8B-B68B-DEC1DC2A3813}" type="datetime6">
               <a:rPr lang="ko-KR" altLang="en-US" smtClean="0"/>
-              <a:t>2024년 5월</a:t>
+              <a:t>2024년 6월</a:t>
             </a:fld>
             <a:endParaRPr lang="ko-KR" altLang="en-US"/>
           </a:p>
@@ -11472,7 +11472,7 @@
           <p:nvPr userDrawn="1"/>
         </p:nvPicPr>
         <p:blipFill>
-          <a:blip r:embed="rId14">
+          <a:blip r:embed="rId14" cstate="hqprint">
             <a:extLst>
               <a:ext uri="{28A0092B-C50C-407E-A947-70E740481C1C}">
                 <a14:useLocalDpi xmlns:a14="http://schemas.microsoft.com/office/drawing/2010/main" val="0"/>
@@ -11886,7 +11886,7 @@
           <a:p>
             <a:fld id="{2932940B-EF53-4BFE-830C-F24863DE5E50}" type="datetime6">
               <a:rPr lang="ko-KR" altLang="en-US" smtClean="0"/>
-              <a:t>2024년 5월</a:t>
+              <a:t>2024년 6월</a:t>
             </a:fld>
             <a:endParaRPr lang="ko-KR" altLang="en-US" dirty="0"/>
           </a:p>
@@ -12038,7 +12038,7 @@
           <a:p>
             <a:fld id="{AD455FBF-1980-4364-9E8B-5E28EBE09C05}" type="datetime6">
               <a:rPr lang="ko-KR" altLang="en-US" smtClean="0"/>
-              <a:t>2024년 5월</a:t>
+              <a:t>2024년 6월</a:t>
             </a:fld>
             <a:endParaRPr lang="ko-KR" altLang="en-US"/>
           </a:p>
@@ -12410,7 +12410,7 @@
           <a:p>
             <a:fld id="{5E4B845D-2417-4568-8665-C368068EE0D6}" type="datetime6">
               <a:rPr lang="ko-KR" altLang="en-US" smtClean="0"/>
-              <a:t>2024년 5월</a:t>
+              <a:t>2024년 6월</a:t>
             </a:fld>
             <a:endParaRPr lang="ko-KR" altLang="en-US"/>
           </a:p>
@@ -12606,7 +12606,7 @@
           <a:p>
             <a:fld id="{9D0404D9-6A52-4A99-9101-80BD6AA53C94}" type="datetime6">
               <a:rPr lang="ko-KR" altLang="en-US" smtClean="0"/>
-              <a:t>2024년 5월</a:t>
+              <a:t>2024년 6월</a:t>
             </a:fld>
             <a:endParaRPr lang="ko-KR" altLang="en-US"/>
           </a:p>
@@ -12729,7 +12729,7 @@
           <a:p>
             <a:fld id="{0E19CB95-6D28-40F1-9DA3-1BAC5D4B5B4F}" type="datetime6">
               <a:rPr lang="ko-KR" altLang="en-US" smtClean="0"/>
-              <a:t>2024년 5월</a:t>
+              <a:t>2024년 6월</a:t>
             </a:fld>
             <a:endParaRPr lang="ko-KR" altLang="en-US"/>
           </a:p>
@@ -13028,7 +13028,7 @@
             <a:fld id="{6545E013-D6A7-47C7-842F-053F23C80D44}" type="datetime6">
               <a:rPr lang="ko-KR" altLang="en-US" smtClean="0"/>
               <a:pPr/>
-              <a:t>2024년 5월</a:t>
+              <a:t>2024년 6월</a:t>
             </a:fld>
             <a:endParaRPr lang="ko-KR" altLang="en-US"/>
           </a:p>
@@ -13299,7 +13299,7 @@
             <a:fld id="{6545E013-D6A7-47C7-842F-053F23C80D44}" type="datetime6">
               <a:rPr lang="ko-KR" altLang="en-US" smtClean="0"/>
               <a:pPr/>
-              <a:t>2024년 5월</a:t>
+              <a:t>2024년 6월</a:t>
             </a:fld>
             <a:endParaRPr lang="ko-KR" altLang="en-US"/>
           </a:p>
@@ -13668,7 +13668,7 @@
           <a:p>
             <a:fld id="{294555BB-40C1-49F2-814A-FC989E48DA17}" type="datetime6">
               <a:rPr lang="ko-KR" altLang="en-US" smtClean="0"/>
-              <a:t>2024년 5월</a:t>
+              <a:t>2024년 6월</a:t>
             </a:fld>
             <a:endParaRPr lang="ko-KR" altLang="en-US"/>
           </a:p>
@@ -13861,7 +13861,7 @@
           <a:p>
             <a:fld id="{D2E2A22E-3498-4C32-970F-84BAFA956A09}" type="datetime6">
               <a:rPr lang="ko-KR" altLang="en-US" smtClean="0"/>
-              <a:t>2024년 5월</a:t>
+              <a:t>2024년 6월</a:t>
             </a:fld>
             <a:endParaRPr lang="ko-KR" altLang="en-US"/>
           </a:p>
@@ -14223,7 +14223,7 @@
             <a:fld id="{6545E013-D6A7-47C7-842F-053F23C80D44}" type="datetime6">
               <a:rPr lang="ko-KR" altLang="en-US" smtClean="0"/>
               <a:pPr/>
-              <a:t>2024년 5월</a:t>
+              <a:t>2024년 6월</a:t>
             </a:fld>
             <a:endParaRPr lang="ko-KR" altLang="en-US"/>
           </a:p>
@@ -14570,7 +14570,7 @@
           <a:p>
             <a:fld id="{0E19CB95-6D28-40F1-9DA3-1BAC5D4B5B4F}" type="datetime6">
               <a:rPr lang="ko-KR" altLang="en-US" smtClean="0"/>
-              <a:t>2024년 5월</a:t>
+              <a:t>2024년 6월</a:t>
             </a:fld>
             <a:endParaRPr lang="ko-KR" altLang="en-US"/>
           </a:p>
@@ -14675,7 +14675,7 @@
           <a:p>
             <a:fld id="{4D8BB8F7-56EA-4444-8715-36E88B2971AE}" type="datetime6">
               <a:rPr lang="ko-KR" altLang="en-US" smtClean="0"/>
-              <a:t>2024년 5월</a:t>
+              <a:t>2024년 6월</a:t>
             </a:fld>
             <a:endParaRPr lang="ko-KR" altLang="en-US"/>
           </a:p>
@@ -14911,7 +14911,7 @@
             <a:fld id="{6545E013-D6A7-47C7-842F-053F23C80D44}" type="datetime6">
               <a:rPr lang="ko-KR" altLang="en-US" smtClean="0"/>
               <a:pPr/>
-              <a:t>2024년 5월</a:t>
+              <a:t>2024년 6월</a:t>
             </a:fld>
             <a:endParaRPr lang="ko-KR" altLang="en-US"/>
           </a:p>
@@ -15069,6 +15069,10 @@
               <a:rPr lang="ko-KR" altLang="en-US" sz="2400" dirty="0"/>
               <a:t>주어진 데이터를 시각적인 형태로 변환하는 과정</a:t>
             </a:r>
+            <a:r>
+              <a:rPr lang="en-US" altLang="ko-KR" sz="2400" dirty="0"/>
+              <a:t/>
+            </a:r>
             <a:br>
               <a:rPr lang="en-US" altLang="ko-KR" sz="2400" dirty="0"/>
             </a:br>
@@ -15190,6 +15194,10 @@
             <a:r>
               <a:rPr lang="ko-KR" altLang="en-US" sz="2400" dirty="0"/>
               <a:t>웹 페이지 리소스를 해석하고 표시하는 역할</a:t>
+            </a:r>
+            <a:r>
+              <a:rPr lang="en-US" altLang="ko-KR" sz="2400" dirty="0"/>
+              <a:t/>
             </a:r>
             <a:br>
               <a:rPr lang="en-US" altLang="ko-KR" sz="2400" dirty="0"/>
@@ -15359,7 +15367,7 @@
             <a:fld id="{6545E013-D6A7-47C7-842F-053F23C80D44}" type="datetime6">
               <a:rPr lang="ko-KR" altLang="en-US" smtClean="0"/>
               <a:pPr/>
-              <a:t>2024년 5월</a:t>
+              <a:t>2024년 6월</a:t>
             </a:fld>
             <a:endParaRPr lang="ko-KR" altLang="en-US"/>
           </a:p>
@@ -15711,7 +15719,7 @@
             <a:fld id="{6545E013-D6A7-47C7-842F-053F23C80D44}" type="datetime6">
               <a:rPr lang="ko-KR" altLang="en-US" smtClean="0"/>
               <a:pPr/>
-              <a:t>2024년 5월</a:t>
+              <a:t>2024년 6월</a:t>
             </a:fld>
             <a:endParaRPr lang="ko-KR" altLang="en-US"/>
           </a:p>
@@ -15863,7 +15871,7 @@
           <a:p>
             <a:fld id="{3CC1F80D-3619-47B0-B506-C15A2DD33094}" type="datetime6">
               <a:rPr lang="ko-KR" altLang="en-US" smtClean="0"/>
-              <a:t>2024년 5월</a:t>
+              <a:t>2024년 6월</a:t>
             </a:fld>
             <a:endParaRPr lang="ko-KR" altLang="en-US"/>
           </a:p>
@@ -16210,7 +16218,7 @@
           <a:p>
             <a:fld id="{185AB4C8-8E0F-4E71-95F4-BC1A3913D5AA}" type="datetime6">
               <a:rPr lang="ko-KR" altLang="en-US" smtClean="0"/>
-              <a:t>2024년 5월</a:t>
+              <a:t>2024년 6월</a:t>
             </a:fld>
             <a:endParaRPr lang="ko-KR" altLang="en-US"/>
           </a:p>
@@ -16557,7 +16565,7 @@
           <a:p>
             <a:fld id="{0E19CB95-6D28-40F1-9DA3-1BAC5D4B5B4F}" type="datetime6">
               <a:rPr lang="ko-KR" altLang="en-US" smtClean="0"/>
-              <a:t>2024년 5월</a:t>
+              <a:t>2024년 6월</a:t>
             </a:fld>
             <a:endParaRPr lang="ko-KR" altLang="en-US"/>
           </a:p>
@@ -16821,7 +16829,7 @@
             <a:fld id="{6545E013-D6A7-47C7-842F-053F23C80D44}" type="datetime6">
               <a:rPr lang="ko-KR" altLang="en-US" smtClean="0"/>
               <a:pPr/>
-              <a:t>2024년 5월</a:t>
+              <a:t>2024년 6월</a:t>
             </a:fld>
             <a:endParaRPr lang="ko-KR" altLang="en-US"/>
           </a:p>
@@ -17038,7 +17046,7 @@
           <a:p>
             <a:fld id="{1041DC4A-5795-4B01-9D97-4D581D89A2E2}" type="datetime6">
               <a:rPr lang="ko-KR" altLang="en-US" smtClean="0"/>
-              <a:t>2024년 5월</a:t>
+              <a:t>2024년 6월</a:t>
             </a:fld>
             <a:endParaRPr lang="ko-KR" altLang="en-US"/>
           </a:p>
@@ -17152,7 +17160,7 @@
           <a:p>
             <a:fld id="{0E19CB95-6D28-40F1-9DA3-1BAC5D4B5B4F}" type="datetime6">
               <a:rPr lang="ko-KR" altLang="en-US" smtClean="0"/>
-              <a:t>2024년 5월</a:t>
+              <a:t>2024년 6월</a:t>
             </a:fld>
             <a:endParaRPr lang="ko-KR" altLang="en-US"/>
           </a:p>
@@ -17411,7 +17419,7 @@
         </p:spPr>
         <p:txBody>
           <a:bodyPr>
-            <a:normAutofit lnSpcReduction="10000"/>
+            <a:normAutofit fontScale="92500"/>
           </a:bodyPr>
           <a:lstStyle/>
           <a:p>
@@ -17797,7 +17805,7 @@
             <a:fld id="{6545E013-D6A7-47C7-842F-053F23C80D44}" type="datetime6">
               <a:rPr lang="ko-KR" altLang="en-US" smtClean="0"/>
               <a:pPr/>
-              <a:t>2024년 5월</a:t>
+              <a:t>2024년 6월</a:t>
             </a:fld>
             <a:endParaRPr lang="ko-KR" altLang="en-US"/>
           </a:p>
@@ -17911,7 +17919,7 @@
           <a:p>
             <a:fld id="{0E19CB95-6D28-40F1-9DA3-1BAC5D4B5B4F}" type="datetime6">
               <a:rPr lang="ko-KR" altLang="en-US" smtClean="0"/>
-              <a:t>2024년 5월</a:t>
+              <a:t>2024년 6월</a:t>
             </a:fld>
             <a:endParaRPr lang="ko-KR" altLang="en-US"/>
           </a:p>
@@ -18917,6 +18925,16 @@
             </a:r>
           </a:p>
           <a:p>
+            <a:r>
+              <a:rPr lang="en-US" altLang="ko-KR" b="0" dirty="0">
+                <a:solidFill>
+                  <a:srgbClr val="D4D4D4"/>
+                </a:solidFill>
+                <a:effectLst/>
+                <a:latin typeface="Consolas" panose="020B0609020204030204" pitchFamily="49" charset="0"/>
+              </a:rPr>
+              <a:t/>
+            </a:r>
             <a:br>
               <a:rPr lang="en-US" altLang="ko-KR" b="0" dirty="0">
                 <a:solidFill>
@@ -18988,6 +19006,16 @@
             </a:r>
           </a:p>
           <a:p>
+            <a:r>
+              <a:rPr lang="en-US" altLang="ko-KR" b="0" dirty="0">
+                <a:solidFill>
+                  <a:srgbClr val="D4D4D4"/>
+                </a:solidFill>
+                <a:effectLst/>
+                <a:latin typeface="Consolas" panose="020B0609020204030204" pitchFamily="49" charset="0"/>
+              </a:rPr>
+              <a:t/>
+            </a:r>
             <a:br>
               <a:rPr lang="en-US" altLang="ko-KR" b="0" dirty="0">
                 <a:solidFill>
@@ -20644,7 +20672,7 @@
         </p:spPr>
         <p:txBody>
           <a:bodyPr>
-            <a:normAutofit lnSpcReduction="10000"/>
+            <a:normAutofit fontScale="92500" lnSpcReduction="10000"/>
           </a:bodyPr>
           <a:lstStyle/>
           <a:p>
@@ -20965,7 +20993,7 @@
             <a:fld id="{6545E013-D6A7-47C7-842F-053F23C80D44}" type="datetime6">
               <a:rPr lang="ko-KR" altLang="en-US" smtClean="0"/>
               <a:pPr/>
-              <a:t>2024년 5월</a:t>
+              <a:t>2024년 6월</a:t>
             </a:fld>
             <a:endParaRPr lang="ko-KR" altLang="en-US"/>
           </a:p>
@@ -21381,7 +21409,7 @@
         </p:spPr>
         <p:txBody>
           <a:bodyPr vert="horz" lIns="91440" tIns="45720" rIns="91440" bIns="45720" rtlCol="0" anchor="ctr">
-            <a:normAutofit fontScale="92500"/>
+            <a:normAutofit fontScale="85000" lnSpcReduction="10000"/>
           </a:bodyPr>
           <a:lstStyle>
             <a:lvl1pPr algn="l" defTabSz="914400" rtl="0" eaLnBrk="1" latinLnBrk="1" hangingPunct="1">
@@ -23438,7 +23466,7 @@
             <a:fld id="{6545E013-D6A7-47C7-842F-053F23C80D44}" type="datetime6">
               <a:rPr lang="ko-KR" altLang="en-US" smtClean="0"/>
               <a:pPr/>
-              <a:t>2024년 5월</a:t>
+              <a:t>2024년 6월</a:t>
             </a:fld>
             <a:endParaRPr lang="ko-KR" altLang="en-US"/>
           </a:p>
@@ -24096,7 +24124,7 @@
           <a:p>
             <a:fld id="{0E19CD00-0CDA-45A7-A8BD-749BE07CE984}" type="datetime6">
               <a:rPr lang="ko-KR" altLang="en-US" smtClean="0"/>
-              <a:t>2024년 5월</a:t>
+              <a:t>2024년 6월</a:t>
             </a:fld>
             <a:endParaRPr lang="ko-KR" altLang="en-US"/>
           </a:p>
@@ -24912,7 +24940,7 @@
             <a:fld id="{6545E013-D6A7-47C7-842F-053F23C80D44}" type="datetime6">
               <a:rPr lang="ko-KR" altLang="en-US" smtClean="0"/>
               <a:pPr/>
-              <a:t>2024년 5월</a:t>
+              <a:t>2024년 6월</a:t>
             </a:fld>
             <a:endParaRPr lang="ko-KR" altLang="en-US" dirty="0"/>
           </a:p>
@@ -25037,22 +25065,16 @@
               <a:t>  </a:t>
             </a:r>
             <a:r>
-              <a:rPr lang="ko-KR" altLang="en-US" sz="5400" dirty="0">
+              <a:rPr lang="ko-KR" altLang="en-US" sz="5400" smtClean="0">
                 <a:solidFill>
                   <a:srgbClr val="FF0000"/>
                 </a:solidFill>
                 <a:effectLst/>
               </a:rPr>
-              <a:t>차이점</a:t>
-            </a:r>
-            <a:r>
-              <a:rPr lang="ko-KR" altLang="en-US" sz="5400" dirty="0">
-                <a:effectLst/>
-              </a:rPr>
-              <a:t>은</a:t>
-            </a:r>
-            <a:r>
-              <a:rPr lang="en-US" altLang="ko-KR" sz="5400" dirty="0">
+              <a:t>차이</a:t>
+            </a:r>
+            <a:r>
+              <a:rPr lang="en-US" altLang="ko-KR" sz="5400" smtClean="0">
                 <a:effectLst/>
               </a:rPr>
               <a:t>?</a:t>
@@ -25694,7 +25716,7 @@
             <a:fld id="{6545E013-D6A7-47C7-842F-053F23C80D44}" type="datetime6">
               <a:rPr lang="ko-KR" altLang="en-US" smtClean="0"/>
               <a:pPr/>
-              <a:t>2024년 5월</a:t>
+              <a:t>2024년 6월</a:t>
             </a:fld>
             <a:endParaRPr lang="ko-KR" altLang="en-US" dirty="0"/>
           </a:p>
@@ -25820,25 +25842,19 @@
             </a:r>
             <a:r>
               <a:rPr lang="en-US" altLang="ko-KR" sz="5400" dirty="0"/>
-              <a:t>  </a:t>
-            </a:r>
-            <a:r>
-              <a:rPr lang="ko-KR" altLang="en-US" sz="5400" dirty="0">
+              <a:t> </a:t>
+            </a:r>
+            <a:r>
+              <a:rPr lang="ko-KR" altLang="en-US" sz="5400" dirty="0" smtClean="0">
                 <a:solidFill>
                   <a:srgbClr val="FF0000"/>
                 </a:solidFill>
                 <a:effectLst/>
               </a:rPr>
-              <a:t>차이점</a:t>
-            </a:r>
-            <a:r>
-              <a:rPr lang="ko-KR" altLang="en-US" sz="5400" dirty="0">
-                <a:effectLst/>
-              </a:rPr>
-              <a:t>은</a:t>
-            </a:r>
-            <a:r>
-              <a:rPr lang="en-US" altLang="ko-KR" sz="5400" dirty="0">
+              <a:t>차이</a:t>
+            </a:r>
+            <a:r>
+              <a:rPr lang="en-US" altLang="ko-KR" sz="5400" dirty="0" smtClean="0">
                 <a:effectLst/>
               </a:rPr>
               <a:t>?</a:t>
@@ -26095,7 +26111,7 @@
           <a:p>
             <a:fld id="{58C994F4-268E-4B47-97B8-5DBF3FCF6BBF}" type="datetime6">
               <a:rPr lang="ko-KR" altLang="en-US" smtClean="0"/>
-              <a:t>2024년 5월</a:t>
+              <a:t>2024년 6월</a:t>
             </a:fld>
             <a:endParaRPr lang="ko-KR" altLang="en-US"/>
           </a:p>
@@ -26333,7 +26349,7 @@
         </p:spPr>
         <p:txBody>
           <a:bodyPr>
-            <a:normAutofit/>
+            <a:normAutofit lnSpcReduction="10000"/>
           </a:bodyPr>
           <a:lstStyle/>
           <a:p>
@@ -26469,7 +26485,7 @@
           <a:p>
             <a:fld id="{BB9625C5-EB1E-432B-A1EC-7DC8377B728C}" type="datetime6">
               <a:rPr lang="ko-KR" altLang="en-US" smtClean="0"/>
-              <a:t>2024년 5월</a:t>
+              <a:t>2024년 6월</a:t>
             </a:fld>
             <a:endParaRPr lang="ko-KR" altLang="en-US"/>
           </a:p>
@@ -26625,7 +26641,7 @@
           <a:p>
             <a:fld id="{0E19CB95-6D28-40F1-9DA3-1BAC5D4B5B4F}" type="datetime6">
               <a:rPr lang="ko-KR" altLang="en-US" smtClean="0"/>
-              <a:t>2024년 5월</a:t>
+              <a:t>2024년 6월</a:t>
             </a:fld>
             <a:endParaRPr lang="ko-KR" altLang="en-US"/>
           </a:p>
@@ -26677,6 +26693,10 @@
             <a:r>
               <a:rPr lang="ko-KR" altLang="en-US" sz="7200" dirty="0"/>
               <a:t>이벤트 </a:t>
+            </a:r>
+            <a:r>
+              <a:rPr lang="en-US" altLang="ko-KR" sz="7200" dirty="0"/>
+              <a:t/>
             </a:r>
             <a:br>
               <a:rPr lang="en-US" altLang="ko-KR" sz="7200" dirty="0"/>
@@ -27165,6 +27185,16 @@
             </a:r>
           </a:p>
           <a:p>
+            <a:r>
+              <a:rPr lang="en-US" altLang="ko-KR" b="0" dirty="0">
+                <a:solidFill>
+                  <a:srgbClr val="D4D4D4"/>
+                </a:solidFill>
+                <a:effectLst/>
+                <a:latin typeface="Consolas" panose="020B0609020204030204" pitchFamily="49" charset="0"/>
+              </a:rPr>
+              <a:t/>
+            </a:r>
             <a:br>
               <a:rPr lang="en-US" altLang="ko-KR" b="0" dirty="0">
                 <a:solidFill>
@@ -27236,6 +27266,16 @@
             </a:r>
           </a:p>
           <a:p>
+            <a:r>
+              <a:rPr lang="en-US" altLang="ko-KR" b="0" dirty="0">
+                <a:solidFill>
+                  <a:srgbClr val="D4D4D4"/>
+                </a:solidFill>
+                <a:effectLst/>
+                <a:latin typeface="Consolas" panose="020B0609020204030204" pitchFamily="49" charset="0"/>
+              </a:rPr>
+              <a:t/>
+            </a:r>
             <a:br>
               <a:rPr lang="en-US" altLang="ko-KR" b="0" dirty="0">
                 <a:solidFill>
@@ -28192,7 +28232,7 @@
         </p:spPr>
         <p:txBody>
           <a:bodyPr vert="horz" lIns="91440" tIns="45720" rIns="91440" bIns="45720" rtlCol="0">
-            <a:normAutofit fontScale="77500" lnSpcReduction="20000"/>
+            <a:normAutofit fontScale="70000" lnSpcReduction="20000"/>
           </a:bodyPr>
           <a:lstStyle>
             <a:lvl1pPr marL="228600" indent="-228600" algn="l" defTabSz="914400" rtl="0" eaLnBrk="1" latinLnBrk="1" hangingPunct="1">
@@ -28870,7 +28910,7 @@
           <a:p>
             <a:fld id="{08BBA0DC-E9D2-429C-946B-770A90481327}" type="datetime6">
               <a:rPr lang="ko-KR" altLang="en-US" smtClean="0"/>
-              <a:t>2024년 5월</a:t>
+              <a:t>2024년 6월</a:t>
             </a:fld>
             <a:endParaRPr lang="ko-KR" altLang="en-US"/>
           </a:p>
@@ -29273,7 +29313,7 @@
           <a:p>
             <a:fld id="{08BBA0DC-E9D2-429C-946B-770A90481327}" type="datetime6">
               <a:rPr lang="ko-KR" altLang="en-US" smtClean="0"/>
-              <a:t>2024년 5월</a:t>
+              <a:t>2024년 6월</a:t>
             </a:fld>
             <a:endParaRPr lang="ko-KR" altLang="en-US"/>
           </a:p>
@@ -29434,7 +29474,7 @@
           <a:p>
             <a:fld id="{994F3061-A8C0-47A7-B70C-8C6BAF46AF2C}" type="datetime6">
               <a:rPr lang="ko-KR" altLang="en-US" smtClean="0"/>
-              <a:t>2024년 5월</a:t>
+              <a:t>2024년 6월</a:t>
             </a:fld>
             <a:endParaRPr lang="ko-KR" altLang="en-US"/>
           </a:p>
@@ -29963,7 +30003,7 @@
           <a:p>
             <a:fld id="{528A7B7B-B510-4FB4-806A-F48FB70E79E6}" type="datetime6">
               <a:rPr lang="ko-KR" altLang="en-US" smtClean="0"/>
-              <a:t>2024년 5월</a:t>
+              <a:t>2024년 6월</a:t>
             </a:fld>
             <a:endParaRPr lang="ko-KR" altLang="en-US"/>
           </a:p>
@@ -30598,7 +30638,7 @@
           <a:p>
             <a:fld id="{271A29E6-51E5-434F-8BAA-E4A5A5BCFF40}" type="datetime6">
               <a:rPr lang="ko-KR" altLang="en-US" smtClean="0"/>
-              <a:t>2024년 5월</a:t>
+              <a:t>2024년 6월</a:t>
             </a:fld>
             <a:endParaRPr lang="ko-KR" altLang="en-US"/>
           </a:p>

</xml_diff>

<commit_message>
JS 수업 준비 - 24.06.03
</commit_message>
<xml_diff>
--- a/material/[SeSAC_YDP_6] 04_5_Javascript_표준객체,DOM.pptx
+++ b/material/[SeSAC_YDP_6] 04_5_Javascript_표준객체,DOM.pptx
@@ -7542,36 +7542,12 @@
           <a:lstStyle/>
           <a:p>
             <a:r>
-              <a:rPr lang="ko-KR" altLang="en-US" sz="1200" dirty="0" err="1">
-                <a:highlight>
-                  <a:srgbClr val="FFFF00"/>
-                </a:highlight>
-              </a:rPr>
-              <a:t>변수선언</a:t>
-            </a:r>
-            <a:r>
               <a:rPr lang="ko-KR" altLang="en-US" sz="1200" dirty="0">
                 <a:highlight>
                   <a:srgbClr val="FFFF00"/>
                 </a:highlight>
               </a:rPr>
-              <a:t> 안하고 </a:t>
-            </a:r>
-            <a:r>
-              <a:rPr lang="ko-KR" altLang="en-US" sz="1200" dirty="0" err="1">
-                <a:highlight>
-                  <a:srgbClr val="FFFF00"/>
-                </a:highlight>
-              </a:rPr>
-              <a:t>메소드</a:t>
-            </a:r>
-            <a:r>
-              <a:rPr lang="ko-KR" altLang="en-US" sz="1200" dirty="0">
-                <a:highlight>
-                  <a:srgbClr val="FFFF00"/>
-                </a:highlight>
-              </a:rPr>
-              <a:t> </a:t>
+              <a:t>변수 선언 안하고 메소드 </a:t>
             </a:r>
             <a:r>
               <a:rPr lang="ko-KR" altLang="en-US" sz="1200" dirty="0" err="1">
@@ -15455,10 +15431,9 @@
               <a:t>. </a:t>
             </a:r>
             <a:r>
-              <a:rPr lang="ko-KR" altLang="en-US" dirty="0" smtClean="0"/>
+              <a:rPr lang="ko-KR" altLang="en-US" dirty="0"/>
               <a:t>주말과 평일</a:t>
             </a:r>
-            <a:endParaRPr lang="ko-KR" altLang="en-US" dirty="0"/>
           </a:p>
         </p:txBody>
       </p:sp>
@@ -15732,15 +15707,6 @@
               </a:rPr>
               <a:t>강의 클릭</a:t>
             </a:r>
-            <a:r>
-              <a:rPr lang="en-US" altLang="ko-KR" dirty="0">
-                <a:solidFill>
-                  <a:srgbClr val="212529"/>
-                </a:solidFill>
-                <a:latin typeface="+mn-ea"/>
-              </a:rPr>
-              <a:t/>
-            </a:r>
             <a:br>
               <a:rPr lang="en-US" altLang="ko-KR" dirty="0">
                 <a:solidFill>
@@ -15768,7 +15734,7 @@
               <a:t>➡ </a:t>
             </a:r>
             <a:r>
-              <a:rPr lang="en-US" altLang="ko-KR" sz="2800" b="1" dirty="0" smtClean="0">
+              <a:rPr lang="en-US" altLang="ko-KR" sz="2800" b="1" dirty="0">
                 <a:solidFill>
                   <a:srgbClr val="212529"/>
                 </a:solidFill>
@@ -15777,7 +15743,7 @@
               <a:t>[</a:t>
             </a:r>
             <a:r>
-              <a:rPr lang="ko-KR" altLang="en-US" sz="2800" b="1" dirty="0" smtClean="0">
+              <a:rPr lang="ko-KR" altLang="en-US" sz="2800" b="1" dirty="0">
                 <a:solidFill>
                   <a:srgbClr val="212529"/>
                 </a:solidFill>
@@ -15786,7 +15752,7 @@
               <a:t>내장 </a:t>
             </a:r>
             <a:r>
-              <a:rPr lang="ko-KR" altLang="en-US" sz="2800" b="1" dirty="0" err="1" smtClean="0">
+              <a:rPr lang="ko-KR" altLang="en-US" sz="2800" b="1" dirty="0" err="1">
                 <a:solidFill>
                   <a:srgbClr val="212529"/>
                 </a:solidFill>
@@ -15795,7 +15761,7 @@
               <a:t>메소드와</a:t>
             </a:r>
             <a:r>
-              <a:rPr lang="ko-KR" altLang="en-US" sz="2800" b="1" dirty="0" smtClean="0">
+              <a:rPr lang="ko-KR" altLang="en-US" sz="2800" b="1" dirty="0">
                 <a:solidFill>
                   <a:srgbClr val="212529"/>
                 </a:solidFill>
@@ -15804,7 +15770,7 @@
               <a:t> 내장 객체 실습</a:t>
             </a:r>
             <a:r>
-              <a:rPr lang="en-US" altLang="ko-KR" sz="2800" b="1" dirty="0" smtClean="0">
+              <a:rPr lang="en-US" altLang="ko-KR" sz="2800" b="1" dirty="0">
                 <a:solidFill>
                   <a:srgbClr val="212529"/>
                 </a:solidFill>
@@ -15813,7 +15779,7 @@
               <a:t>]</a:t>
             </a:r>
             <a:r>
-              <a:rPr lang="en-US" altLang="ko-KR" sz="2800" dirty="0" smtClean="0">
+              <a:rPr lang="en-US" altLang="ko-KR" sz="2800" dirty="0">
                 <a:solidFill>
                   <a:srgbClr val="212529"/>
                 </a:solidFill>
@@ -15849,7 +15815,7 @@
               <a:t>➡ </a:t>
             </a:r>
             <a:r>
-              <a:rPr lang="en-US" altLang="ko-KR" sz="2800" b="1" dirty="0" smtClean="0">
+              <a:rPr lang="en-US" altLang="ko-KR" sz="2800" b="1" dirty="0">
                 <a:solidFill>
                   <a:schemeClr val="accent1"/>
                 </a:solidFill>
@@ -15858,7 +15824,7 @@
               <a:t>[</a:t>
             </a:r>
             <a:r>
-              <a:rPr lang="ko-KR" altLang="en-US" sz="2800" b="1" dirty="0" smtClean="0">
+              <a:rPr lang="ko-KR" altLang="en-US" sz="2800" b="1" dirty="0">
                 <a:solidFill>
                   <a:schemeClr val="accent1"/>
                 </a:solidFill>
@@ -15867,7 +15833,7 @@
               <a:t>내장 객체 </a:t>
             </a:r>
             <a:r>
-              <a:rPr lang="ko-KR" altLang="en-US" sz="2800" b="1" dirty="0" err="1" smtClean="0">
+              <a:rPr lang="ko-KR" altLang="en-US" sz="2800" b="1" dirty="0" err="1">
                 <a:solidFill>
                   <a:schemeClr val="accent1"/>
                 </a:solidFill>
@@ -15876,7 +15842,7 @@
               <a:t>실습문제</a:t>
             </a:r>
             <a:r>
-              <a:rPr lang="en-US" altLang="ko-KR" sz="2800" b="1" dirty="0" smtClean="0">
+              <a:rPr lang="en-US" altLang="ko-KR" sz="2800" b="1" dirty="0">
                 <a:solidFill>
                   <a:schemeClr val="accent1"/>
                 </a:solidFill>
@@ -15885,7 +15851,7 @@
               <a:t>1. </a:t>
             </a:r>
             <a:r>
-              <a:rPr lang="ko-KR" altLang="en-US" sz="2800" b="1" dirty="0" smtClean="0">
+              <a:rPr lang="ko-KR" altLang="en-US" sz="2800" b="1" dirty="0">
                 <a:solidFill>
                   <a:schemeClr val="accent1"/>
                 </a:solidFill>
@@ -15894,7 +15860,7 @@
               <a:t>주말과 평일</a:t>
             </a:r>
             <a:r>
-              <a:rPr lang="en-US" altLang="ko-KR" sz="2800" b="1" dirty="0" smtClean="0">
+              <a:rPr lang="en-US" altLang="ko-KR" sz="2800" b="1" dirty="0">
                 <a:solidFill>
                   <a:schemeClr val="accent1"/>
                 </a:solidFill>
@@ -15903,7 +15869,7 @@
               <a:t> ]</a:t>
             </a:r>
             <a:r>
-              <a:rPr lang="en-US" altLang="ko-KR" sz="2800" dirty="0" smtClean="0">
+              <a:rPr lang="en-US" altLang="ko-KR" sz="2800" dirty="0">
                 <a:solidFill>
                   <a:schemeClr val="accent1"/>
                 </a:solidFill>
@@ -15912,22 +15878,13 @@
               <a:t> </a:t>
             </a:r>
             <a:r>
-              <a:rPr lang="ko-KR" altLang="en-US" sz="2800" dirty="0" smtClean="0">
+              <a:rPr lang="ko-KR" altLang="en-US" sz="2800" dirty="0">
                 <a:solidFill>
                   <a:srgbClr val="212529"/>
                 </a:solidFill>
                 <a:latin typeface="+mn-ea"/>
               </a:rPr>
-              <a:t> </a:t>
-            </a:r>
-            <a:r>
-              <a:rPr lang="ko-KR" altLang="en-US" sz="2800" dirty="0">
-                <a:solidFill>
-                  <a:srgbClr val="212529"/>
-                </a:solidFill>
-                <a:latin typeface="+mn-ea"/>
-              </a:rPr>
-              <a:t>진행</a:t>
+              <a:t> 진행</a:t>
             </a:r>
           </a:p>
         </p:txBody>
@@ -16234,14 +16191,13 @@
               <a:t>. </a:t>
             </a:r>
             <a:r>
-              <a:rPr lang="ko-KR" altLang="en-US" dirty="0" err="1" smtClean="0"/>
+              <a:rPr lang="ko-KR" altLang="en-US" dirty="0" err="1"/>
               <a:t>난수</a:t>
             </a:r>
             <a:r>
-              <a:rPr lang="ko-KR" altLang="en-US" dirty="0" smtClean="0"/>
+              <a:rPr lang="ko-KR" altLang="en-US" dirty="0"/>
               <a:t> 생성</a:t>
             </a:r>
-            <a:endParaRPr lang="ko-KR" altLang="en-US" dirty="0"/>
           </a:p>
         </p:txBody>
       </p:sp>
@@ -16515,15 +16471,6 @@
               </a:rPr>
               <a:t>강의 클릭</a:t>
             </a:r>
-            <a:r>
-              <a:rPr lang="en-US" altLang="ko-KR" dirty="0">
-                <a:solidFill>
-                  <a:srgbClr val="212529"/>
-                </a:solidFill>
-                <a:latin typeface="+mn-ea"/>
-              </a:rPr>
-              <a:t/>
-            </a:r>
             <a:br>
               <a:rPr lang="en-US" altLang="ko-KR" dirty="0">
                 <a:solidFill>
@@ -16551,7 +16498,7 @@
               <a:t>➡ </a:t>
             </a:r>
             <a:r>
-              <a:rPr lang="en-US" altLang="ko-KR" sz="2800" b="1" dirty="0" smtClean="0">
+              <a:rPr lang="en-US" altLang="ko-KR" sz="2800" b="1" dirty="0">
                 <a:solidFill>
                   <a:srgbClr val="212529"/>
                 </a:solidFill>
@@ -16560,7 +16507,7 @@
               <a:t>[</a:t>
             </a:r>
             <a:r>
-              <a:rPr lang="ko-KR" altLang="en-US" sz="2800" b="1" dirty="0" smtClean="0">
+              <a:rPr lang="ko-KR" altLang="en-US" sz="2800" b="1" dirty="0">
                 <a:solidFill>
                   <a:srgbClr val="212529"/>
                 </a:solidFill>
@@ -16569,7 +16516,7 @@
               <a:t>내장 </a:t>
             </a:r>
             <a:r>
-              <a:rPr lang="ko-KR" altLang="en-US" sz="2800" b="1" dirty="0" err="1" smtClean="0">
+              <a:rPr lang="ko-KR" altLang="en-US" sz="2800" b="1" dirty="0" err="1">
                 <a:solidFill>
                   <a:srgbClr val="212529"/>
                 </a:solidFill>
@@ -16578,7 +16525,7 @@
               <a:t>메소드와</a:t>
             </a:r>
             <a:r>
-              <a:rPr lang="ko-KR" altLang="en-US" sz="2800" b="1" dirty="0" smtClean="0">
+              <a:rPr lang="ko-KR" altLang="en-US" sz="2800" b="1" dirty="0">
                 <a:solidFill>
                   <a:srgbClr val="212529"/>
                 </a:solidFill>
@@ -16587,7 +16534,7 @@
               <a:t> 내장 객체 실습</a:t>
             </a:r>
             <a:r>
-              <a:rPr lang="en-US" altLang="ko-KR" sz="2800" b="1" dirty="0" smtClean="0">
+              <a:rPr lang="en-US" altLang="ko-KR" sz="2800" b="1" dirty="0">
                 <a:solidFill>
                   <a:srgbClr val="212529"/>
                 </a:solidFill>
@@ -16596,7 +16543,7 @@
               <a:t>]</a:t>
             </a:r>
             <a:r>
-              <a:rPr lang="en-US" altLang="ko-KR" sz="2800" dirty="0" smtClean="0">
+              <a:rPr lang="en-US" altLang="ko-KR" sz="2800" dirty="0">
                 <a:solidFill>
                   <a:srgbClr val="212529"/>
                 </a:solidFill>
@@ -16632,7 +16579,7 @@
               <a:t>➡ </a:t>
             </a:r>
             <a:r>
-              <a:rPr lang="en-US" altLang="ko-KR" sz="2800" b="1" dirty="0" smtClean="0">
+              <a:rPr lang="en-US" altLang="ko-KR" sz="2800" b="1" dirty="0">
                 <a:solidFill>
                   <a:schemeClr val="accent1"/>
                 </a:solidFill>
@@ -16641,7 +16588,7 @@
               <a:t>[</a:t>
             </a:r>
             <a:r>
-              <a:rPr lang="ko-KR" altLang="en-US" sz="2800" b="1" dirty="0" smtClean="0">
+              <a:rPr lang="ko-KR" altLang="en-US" sz="2800" b="1" dirty="0">
                 <a:solidFill>
                   <a:schemeClr val="accent1"/>
                 </a:solidFill>
@@ -16650,7 +16597,7 @@
               <a:t>내장 객체 </a:t>
             </a:r>
             <a:r>
-              <a:rPr lang="ko-KR" altLang="en-US" sz="2800" b="1" dirty="0" err="1" smtClean="0">
+              <a:rPr lang="ko-KR" altLang="en-US" sz="2800" b="1" dirty="0" err="1">
                 <a:solidFill>
                   <a:schemeClr val="accent1"/>
                 </a:solidFill>
@@ -16659,7 +16606,7 @@
               <a:t>실습문제</a:t>
             </a:r>
             <a:r>
-              <a:rPr lang="en-US" altLang="ko-KR" sz="2800" b="1" dirty="0" smtClean="0">
+              <a:rPr lang="en-US" altLang="ko-KR" sz="2800" b="1" dirty="0">
                 <a:solidFill>
                   <a:schemeClr val="accent1"/>
                 </a:solidFill>
@@ -16668,7 +16615,7 @@
               <a:t>2. </a:t>
             </a:r>
             <a:r>
-              <a:rPr lang="ko-KR" altLang="en-US" sz="2800" b="1" dirty="0" err="1" smtClean="0">
+              <a:rPr lang="ko-KR" altLang="en-US" sz="2800" b="1" dirty="0" err="1">
                 <a:solidFill>
                   <a:schemeClr val="accent1"/>
                 </a:solidFill>
@@ -16677,7 +16624,7 @@
               <a:t>난수</a:t>
             </a:r>
             <a:r>
-              <a:rPr lang="ko-KR" altLang="en-US" sz="2800" b="1" dirty="0" smtClean="0">
+              <a:rPr lang="ko-KR" altLang="en-US" sz="2800" b="1" dirty="0">
                 <a:solidFill>
                   <a:schemeClr val="accent1"/>
                 </a:solidFill>
@@ -16686,7 +16633,7 @@
               <a:t> 생성</a:t>
             </a:r>
             <a:r>
-              <a:rPr lang="en-US" altLang="ko-KR" sz="2800" b="1" dirty="0" smtClean="0">
+              <a:rPr lang="en-US" altLang="ko-KR" sz="2800" b="1" dirty="0">
                 <a:solidFill>
                   <a:schemeClr val="accent1"/>
                 </a:solidFill>
@@ -16695,7 +16642,7 @@
               <a:t>]</a:t>
             </a:r>
             <a:r>
-              <a:rPr lang="en-US" altLang="ko-KR" sz="2800" dirty="0" smtClean="0">
+              <a:rPr lang="en-US" altLang="ko-KR" sz="2800" dirty="0">
                 <a:solidFill>
                   <a:schemeClr val="accent1"/>
                 </a:solidFill>
@@ -16704,22 +16651,13 @@
               <a:t> </a:t>
             </a:r>
             <a:r>
-              <a:rPr lang="ko-KR" altLang="en-US" sz="2800" dirty="0" smtClean="0">
+              <a:rPr lang="ko-KR" altLang="en-US" sz="2800" dirty="0">
                 <a:solidFill>
                   <a:srgbClr val="212529"/>
                 </a:solidFill>
                 <a:latin typeface="+mn-ea"/>
               </a:rPr>
-              <a:t> </a:t>
-            </a:r>
-            <a:r>
-              <a:rPr lang="ko-KR" altLang="en-US" sz="2800" dirty="0">
-                <a:solidFill>
-                  <a:srgbClr val="212529"/>
-                </a:solidFill>
-                <a:latin typeface="+mn-ea"/>
-              </a:rPr>
-              <a:t>진행</a:t>
+              <a:t> 진행</a:t>
             </a:r>
           </a:p>
         </p:txBody>
@@ -17135,10 +17073,6 @@
               <a:rPr lang="ko-KR" altLang="en-US" sz="2400" dirty="0"/>
               <a:t>주어진 데이터를 시각적인 형태로 변환하는 과정</a:t>
             </a:r>
-            <a:r>
-              <a:rPr lang="en-US" altLang="ko-KR" sz="2400" dirty="0"/>
-              <a:t/>
-            </a:r>
             <a:br>
               <a:rPr lang="en-US" altLang="ko-KR" sz="2400" dirty="0"/>
             </a:br>
@@ -17260,10 +17194,6 @@
             <a:r>
               <a:rPr lang="ko-KR" altLang="en-US" sz="2400" dirty="0"/>
               <a:t>웹 페이지 리소스를 해석하고 표시하는 역할</a:t>
-            </a:r>
-            <a:r>
-              <a:rPr lang="en-US" altLang="ko-KR" sz="2400" dirty="0"/>
-              <a:t/>
             </a:r>
             <a:br>
               <a:rPr lang="en-US" altLang="ko-KR" sz="2400" dirty="0"/>
@@ -20991,7 +20921,7 @@
             </a:r>
           </a:p>
           <a:p>
-            <a:r>
+            <a:br>
               <a:rPr lang="en-US" altLang="ko-KR" b="0" dirty="0">
                 <a:solidFill>
                   <a:srgbClr val="D4D4D4"/>
@@ -20999,89 +20929,69 @@
                 <a:effectLst/>
                 <a:latin typeface="Consolas" panose="020B0609020204030204" pitchFamily="49" charset="0"/>
               </a:rPr>
-              <a:t/>
-            </a:r>
-            <a:br>
+            </a:br>
+            <a:r>
               <a:rPr lang="en-US" altLang="ko-KR" b="0" dirty="0">
                 <a:solidFill>
-                  <a:srgbClr val="D4D4D4"/>
+                  <a:srgbClr val="9CDCFE"/>
                 </a:solidFill>
                 <a:effectLst/>
                 <a:latin typeface="Consolas" panose="020B0609020204030204" pitchFamily="49" charset="0"/>
               </a:rPr>
-            </a:br>
+              <a:t>console</a:t>
+            </a:r>
             <a:r>
               <a:rPr lang="en-US" altLang="ko-KR" b="0" dirty="0">
                 <a:solidFill>
-                  <a:srgbClr val="9CDCFE"/>
+                  <a:srgbClr val="D4D4D4"/>
                 </a:solidFill>
                 <a:effectLst/>
                 <a:latin typeface="Consolas" panose="020B0609020204030204" pitchFamily="49" charset="0"/>
               </a:rPr>
-              <a:t>console</a:t>
+              <a:t>.</a:t>
             </a:r>
             <a:r>
               <a:rPr lang="en-US" altLang="ko-KR" b="0" dirty="0">
                 <a:solidFill>
-                  <a:srgbClr val="D4D4D4"/>
+                  <a:srgbClr val="DCDCAA"/>
                 </a:solidFill>
                 <a:effectLst/>
                 <a:latin typeface="Consolas" panose="020B0609020204030204" pitchFamily="49" charset="0"/>
               </a:rPr>
-              <a:t>.</a:t>
+              <a:t>log</a:t>
             </a:r>
             <a:r>
               <a:rPr lang="en-US" altLang="ko-KR" b="0" dirty="0">
                 <a:solidFill>
-                  <a:srgbClr val="DCDCAA"/>
+                  <a:srgbClr val="D4D4D4"/>
                 </a:solidFill>
                 <a:effectLst/>
                 <a:latin typeface="Consolas" panose="020B0609020204030204" pitchFamily="49" charset="0"/>
               </a:rPr>
-              <a:t>log</a:t>
-            </a:r>
-            <a:r>
-              <a:rPr lang="en-US" altLang="ko-KR" b="0" dirty="0">
-                <a:solidFill>
-                  <a:srgbClr val="D4D4D4"/>
+              <a:t>(</a:t>
+            </a:r>
+            <a:r>
+              <a:rPr lang="en-US" altLang="ko-KR" b="0" dirty="0" err="1">
+                <a:solidFill>
+                  <a:srgbClr val="9CDCFE"/>
                 </a:solidFill>
                 <a:effectLst/>
                 <a:latin typeface="Consolas" panose="020B0609020204030204" pitchFamily="49" charset="0"/>
               </a:rPr>
-              <a:t>(</a:t>
-            </a:r>
-            <a:r>
-              <a:rPr lang="en-US" altLang="ko-KR" b="0" dirty="0" err="1">
-                <a:solidFill>
-                  <a:srgbClr val="9CDCFE"/>
+              <a:t>boxEl</a:t>
+            </a:r>
+            <a:r>
+              <a:rPr lang="en-US" altLang="ko-KR" b="0" dirty="0">
+                <a:solidFill>
+                  <a:srgbClr val="D4D4D4"/>
                 </a:solidFill>
                 <a:effectLst/>
                 <a:latin typeface="Consolas" panose="020B0609020204030204" pitchFamily="49" charset="0"/>
               </a:rPr>
-              <a:t>boxEl</a:t>
-            </a:r>
-            <a:r>
-              <a:rPr lang="en-US" altLang="ko-KR" b="0" dirty="0">
-                <a:solidFill>
-                  <a:srgbClr val="D4D4D4"/>
-                </a:solidFill>
-                <a:effectLst/>
-                <a:latin typeface="Consolas" panose="020B0609020204030204" pitchFamily="49" charset="0"/>
-              </a:rPr>
               <a:t>);</a:t>
             </a:r>
           </a:p>
           <a:p>
-            <a:r>
-              <a:rPr lang="en-US" altLang="ko-KR" b="0" dirty="0">
-                <a:solidFill>
-                  <a:srgbClr val="D4D4D4"/>
-                </a:solidFill>
-                <a:effectLst/>
-                <a:latin typeface="Consolas" panose="020B0609020204030204" pitchFamily="49" charset="0"/>
-              </a:rPr>
-              <a:t/>
-            </a:r>
             <a:br>
               <a:rPr lang="en-US" altLang="ko-KR" b="0" dirty="0">
                 <a:solidFill>
@@ -25588,25 +25498,16 @@
                   <a:srgbClr val="6EC173"/>
                 </a:solidFill>
               </a:rPr>
-              <a:t>. </a:t>
-            </a:r>
-            <a:r>
-              <a:rPr lang="en-US" altLang="ko-KR" dirty="0">
-                <a:solidFill>
-                  <a:srgbClr val="6EC173"/>
-                </a:solidFill>
-              </a:rPr>
-              <a:t> </a:t>
-            </a:r>
-            <a:r>
-              <a:rPr lang="en-US" altLang="ko-KR" dirty="0" smtClean="0"/>
+              <a:t>.  </a:t>
+            </a:r>
+            <a:r>
+              <a:rPr lang="en-US" altLang="ko-KR" dirty="0"/>
               <a:t>Html </a:t>
             </a:r>
             <a:r>
-              <a:rPr lang="ko-KR" altLang="en-US" dirty="0" smtClean="0"/>
+              <a:rPr lang="ko-KR" altLang="en-US" dirty="0"/>
               <a:t>내용 변경하기</a:t>
             </a:r>
-            <a:endParaRPr lang="ko-KR" altLang="en-US" dirty="0"/>
           </a:p>
         </p:txBody>
       </p:sp>
@@ -25880,15 +25781,6 @@
               </a:rPr>
               <a:t>강의 클릭</a:t>
             </a:r>
-            <a:r>
-              <a:rPr lang="en-US" altLang="ko-KR" dirty="0">
-                <a:solidFill>
-                  <a:srgbClr val="212529"/>
-                </a:solidFill>
-                <a:latin typeface="+mn-ea"/>
-              </a:rPr>
-              <a:t/>
-            </a:r>
             <a:br>
               <a:rPr lang="en-US" altLang="ko-KR" dirty="0">
                 <a:solidFill>
@@ -25916,7 +25808,7 @@
               <a:t>➡ </a:t>
             </a:r>
             <a:r>
-              <a:rPr lang="en-US" altLang="ko-KR" sz="2800" b="1" dirty="0" smtClean="0">
+              <a:rPr lang="en-US" altLang="ko-KR" sz="2800" b="1" dirty="0">
                 <a:solidFill>
                   <a:srgbClr val="212529"/>
                 </a:solidFill>
@@ -25925,7 +25817,7 @@
               <a:t>[</a:t>
             </a:r>
             <a:r>
-              <a:rPr lang="en-US" altLang="ko-KR" sz="2800" b="1" dirty="0" err="1" smtClean="0">
+              <a:rPr lang="en-US" altLang="ko-KR" sz="2800" b="1" dirty="0" err="1">
                 <a:solidFill>
                   <a:srgbClr val="212529"/>
                 </a:solidFill>
@@ -25934,7 +25826,7 @@
               <a:t>Javascript</a:t>
             </a:r>
             <a:r>
-              <a:rPr lang="en-US" altLang="ko-KR" sz="2800" b="1" dirty="0" smtClean="0">
+              <a:rPr lang="en-US" altLang="ko-KR" sz="2800" b="1" dirty="0">
                 <a:solidFill>
                   <a:srgbClr val="212529"/>
                 </a:solidFill>
@@ -25943,7 +25835,7 @@
               <a:t> DOM </a:t>
             </a:r>
             <a:r>
-              <a:rPr lang="ko-KR" altLang="en-US" sz="2800" b="1" dirty="0" smtClean="0">
+              <a:rPr lang="ko-KR" altLang="en-US" sz="2800" b="1" dirty="0">
                 <a:solidFill>
                   <a:srgbClr val="212529"/>
                 </a:solidFill>
@@ -25952,7 +25844,7 @@
               <a:t>실습</a:t>
             </a:r>
             <a:r>
-              <a:rPr lang="en-US" altLang="ko-KR" sz="2800" b="1" dirty="0" smtClean="0">
+              <a:rPr lang="en-US" altLang="ko-KR" sz="2800" b="1" dirty="0">
                 <a:solidFill>
                   <a:srgbClr val="212529"/>
                 </a:solidFill>
@@ -25961,7 +25853,7 @@
               <a:t>(1)]</a:t>
             </a:r>
             <a:r>
-              <a:rPr lang="en-US" altLang="ko-KR" sz="2800" dirty="0" smtClean="0">
+              <a:rPr lang="en-US" altLang="ko-KR" sz="2800" dirty="0">
                 <a:solidFill>
                   <a:srgbClr val="212529"/>
                 </a:solidFill>
@@ -25997,7 +25889,7 @@
               <a:t>➡ </a:t>
             </a:r>
             <a:r>
-              <a:rPr lang="en-US" altLang="ko-KR" sz="2800" b="1" dirty="0" smtClean="0">
+              <a:rPr lang="en-US" altLang="ko-KR" sz="2800" b="1" dirty="0">
                 <a:solidFill>
                   <a:schemeClr val="accent1"/>
                 </a:solidFill>
@@ -26006,7 +25898,7 @@
               <a:t>[</a:t>
             </a:r>
             <a:r>
-              <a:rPr lang="ko-KR" altLang="en-US" sz="2800" b="1" dirty="0" err="1" smtClean="0">
+              <a:rPr lang="ko-KR" altLang="en-US" sz="2800" b="1" dirty="0" err="1">
                 <a:solidFill>
                   <a:schemeClr val="accent1"/>
                 </a:solidFill>
@@ -26015,67 +25907,49 @@
               <a:t>실습문제</a:t>
             </a:r>
             <a:r>
-              <a:rPr lang="en-US" altLang="ko-KR" sz="2800" b="1" dirty="0" smtClean="0">
+              <a:rPr lang="en-US" altLang="ko-KR" sz="2800" b="1" dirty="0">
                 <a:solidFill>
                   <a:schemeClr val="accent1"/>
                 </a:solidFill>
                 <a:latin typeface="+mn-ea"/>
               </a:rPr>
-              <a:t>1. </a:t>
-            </a:r>
-            <a:r>
-              <a:rPr lang="en-US" altLang="ko-KR" sz="2800" b="1" dirty="0" smtClean="0">
+              <a:t>1. html </a:t>
+            </a:r>
+            <a:r>
+              <a:rPr lang="ko-KR" altLang="en-US" sz="2800" b="1" dirty="0">
                 <a:solidFill>
                   <a:schemeClr val="accent1"/>
                 </a:solidFill>
                 <a:latin typeface="+mn-ea"/>
               </a:rPr>
-              <a:t>html </a:t>
-            </a:r>
-            <a:r>
-              <a:rPr lang="ko-KR" altLang="en-US" sz="2800" b="1" dirty="0" smtClean="0">
+              <a:t>내용 변경하기</a:t>
+            </a:r>
+            <a:r>
+              <a:rPr lang="en-US" altLang="ko-KR" sz="2800" b="1" dirty="0">
                 <a:solidFill>
                   <a:schemeClr val="accent1"/>
                 </a:solidFill>
                 <a:latin typeface="+mn-ea"/>
               </a:rPr>
-              <a:t>내용 변경하기</a:t>
-            </a:r>
-            <a:r>
-              <a:rPr lang="en-US" altLang="ko-KR" sz="2800" b="1" dirty="0" smtClean="0">
+              <a:t>]</a:t>
+            </a:r>
+            <a:r>
+              <a:rPr lang="en-US" altLang="ko-KR" sz="2800" dirty="0">
                 <a:solidFill>
                   <a:schemeClr val="accent1"/>
                 </a:solidFill>
                 <a:latin typeface="+mn-ea"/>
               </a:rPr>
-              <a:t>]</a:t>
-            </a:r>
-            <a:r>
-              <a:rPr lang="en-US" altLang="ko-KR" sz="2800" dirty="0" smtClean="0">
-                <a:solidFill>
-                  <a:schemeClr val="accent1"/>
+              <a:t> </a:t>
+            </a:r>
+            <a:r>
+              <a:rPr lang="ko-KR" altLang="en-US" sz="2800" dirty="0">
+                <a:solidFill>
+                  <a:srgbClr val="212529"/>
                 </a:solidFill>
                 <a:latin typeface="+mn-ea"/>
               </a:rPr>
-              <a:t> </a:t>
-            </a:r>
-            <a:r>
-              <a:rPr lang="ko-KR" altLang="en-US" sz="2800" dirty="0" smtClean="0">
-                <a:solidFill>
-                  <a:srgbClr val="212529"/>
-                </a:solidFill>
-                <a:latin typeface="+mn-ea"/>
-              </a:rPr>
-              <a:t> </a:t>
-            </a:r>
-            <a:r>
-              <a:rPr lang="ko-KR" altLang="en-US" sz="2800" dirty="0">
-                <a:solidFill>
-                  <a:srgbClr val="212529"/>
-                </a:solidFill>
-                <a:latin typeface="+mn-ea"/>
-              </a:rPr>
-              <a:t>진행</a:t>
+              <a:t> 진행</a:t>
             </a:r>
           </a:p>
         </p:txBody>
@@ -26244,33 +26118,24 @@
                   <a:srgbClr val="6EC173"/>
                 </a:solidFill>
               </a:rPr>
-              <a:t>. </a:t>
-            </a:r>
-            <a:r>
-              <a:rPr lang="en-US" altLang="ko-KR" dirty="0">
-                <a:solidFill>
-                  <a:srgbClr val="6EC173"/>
-                </a:solidFill>
-              </a:rPr>
+              <a:t>.  </a:t>
+            </a:r>
+            <a:r>
+              <a:rPr lang="en-US" altLang="ko-KR" dirty="0"/>
               <a:t> </a:t>
             </a:r>
             <a:r>
-              <a:rPr lang="en-US" altLang="ko-KR" dirty="0" smtClean="0"/>
+              <a:rPr lang="en-US" altLang="ko-KR" dirty="0" err="1"/>
+              <a:t>TodoList</a:t>
+            </a:r>
+            <a:r>
+              <a:rPr lang="en-US" altLang="ko-KR" dirty="0"/>
               <a:t> </a:t>
             </a:r>
             <a:r>
-              <a:rPr lang="en-US" altLang="ko-KR" dirty="0" err="1" smtClean="0"/>
-              <a:t>TodoList</a:t>
-            </a:r>
-            <a:r>
-              <a:rPr lang="en-US" altLang="ko-KR" dirty="0" smtClean="0"/>
-              <a:t> </a:t>
-            </a:r>
-            <a:r>
-              <a:rPr lang="ko-KR" altLang="en-US" dirty="0" smtClean="0"/>
+              <a:rPr lang="ko-KR" altLang="en-US" dirty="0"/>
               <a:t>변경하기</a:t>
             </a:r>
-            <a:endParaRPr lang="ko-KR" altLang="en-US" dirty="0"/>
           </a:p>
         </p:txBody>
       </p:sp>
@@ -26544,15 +26409,6 @@
               </a:rPr>
               <a:t>강의 클릭</a:t>
             </a:r>
-            <a:r>
-              <a:rPr lang="en-US" altLang="ko-KR" dirty="0">
-                <a:solidFill>
-                  <a:srgbClr val="212529"/>
-                </a:solidFill>
-                <a:latin typeface="+mn-ea"/>
-              </a:rPr>
-              <a:t/>
-            </a:r>
             <a:br>
               <a:rPr lang="en-US" altLang="ko-KR" dirty="0">
                 <a:solidFill>
@@ -26580,7 +26436,7 @@
               <a:t>➡ </a:t>
             </a:r>
             <a:r>
-              <a:rPr lang="en-US" altLang="ko-KR" sz="2800" b="1" dirty="0" smtClean="0">
+              <a:rPr lang="en-US" altLang="ko-KR" sz="2800" b="1" dirty="0">
                 <a:solidFill>
                   <a:srgbClr val="212529"/>
                 </a:solidFill>
@@ -26589,7 +26445,7 @@
               <a:t>[</a:t>
             </a:r>
             <a:r>
-              <a:rPr lang="en-US" altLang="ko-KR" sz="2800" b="1" dirty="0" err="1" smtClean="0">
+              <a:rPr lang="en-US" altLang="ko-KR" sz="2800" b="1" dirty="0" err="1">
                 <a:solidFill>
                   <a:srgbClr val="212529"/>
                 </a:solidFill>
@@ -26598,7 +26454,7 @@
               <a:t>Javascript</a:t>
             </a:r>
             <a:r>
-              <a:rPr lang="en-US" altLang="ko-KR" sz="2800" b="1" dirty="0" smtClean="0">
+              <a:rPr lang="en-US" altLang="ko-KR" sz="2800" b="1" dirty="0">
                 <a:solidFill>
                   <a:srgbClr val="212529"/>
                 </a:solidFill>
@@ -26607,7 +26463,7 @@
               <a:t> DOM </a:t>
             </a:r>
             <a:r>
-              <a:rPr lang="ko-KR" altLang="en-US" sz="2800" b="1" dirty="0" smtClean="0">
+              <a:rPr lang="ko-KR" altLang="en-US" sz="2800" b="1" dirty="0">
                 <a:solidFill>
                   <a:srgbClr val="212529"/>
                 </a:solidFill>
@@ -26616,7 +26472,7 @@
               <a:t>실습</a:t>
             </a:r>
             <a:r>
-              <a:rPr lang="en-US" altLang="ko-KR" sz="2800" b="1" dirty="0" smtClean="0">
+              <a:rPr lang="en-US" altLang="ko-KR" sz="2800" b="1" dirty="0">
                 <a:solidFill>
                   <a:srgbClr val="212529"/>
                 </a:solidFill>
@@ -26625,7 +26481,7 @@
               <a:t>(1)]</a:t>
             </a:r>
             <a:r>
-              <a:rPr lang="en-US" altLang="ko-KR" sz="2800" dirty="0" smtClean="0">
+              <a:rPr lang="en-US" altLang="ko-KR" sz="2800" dirty="0">
                 <a:solidFill>
                   <a:srgbClr val="212529"/>
                 </a:solidFill>
@@ -26661,7 +26517,7 @@
               <a:t>➡ </a:t>
             </a:r>
             <a:r>
-              <a:rPr lang="en-US" altLang="ko-KR" sz="2800" b="1" dirty="0" smtClean="0">
+              <a:rPr lang="en-US" altLang="ko-KR" sz="2800" b="1" dirty="0">
                 <a:solidFill>
                   <a:schemeClr val="accent1"/>
                 </a:solidFill>
@@ -26670,7 +26526,7 @@
               <a:t>[</a:t>
             </a:r>
             <a:r>
-              <a:rPr lang="ko-KR" altLang="en-US" sz="2800" b="1" dirty="0" err="1" smtClean="0">
+              <a:rPr lang="ko-KR" altLang="en-US" sz="2800" b="1" dirty="0" err="1">
                 <a:solidFill>
                   <a:schemeClr val="accent1"/>
                 </a:solidFill>
@@ -26679,7 +26535,7 @@
               <a:t>실습문제</a:t>
             </a:r>
             <a:r>
-              <a:rPr lang="en-US" altLang="ko-KR" sz="2800" b="1" dirty="0" smtClean="0">
+              <a:rPr lang="en-US" altLang="ko-KR" sz="2800" b="1" dirty="0">
                 <a:solidFill>
                   <a:schemeClr val="accent1"/>
                 </a:solidFill>
@@ -26688,7 +26544,7 @@
               <a:t>2. </a:t>
             </a:r>
             <a:r>
-              <a:rPr lang="en-US" altLang="ko-KR" sz="2800" b="1" dirty="0" err="1" smtClean="0">
+              <a:rPr lang="en-US" altLang="ko-KR" sz="2800" b="1" dirty="0" err="1">
                 <a:solidFill>
                   <a:schemeClr val="accent1"/>
                 </a:solidFill>
@@ -26697,7 +26553,7 @@
               <a:t>TodoList</a:t>
             </a:r>
             <a:r>
-              <a:rPr lang="en-US" altLang="ko-KR" sz="2800" b="1" dirty="0" smtClean="0">
+              <a:rPr lang="en-US" altLang="ko-KR" sz="2800" b="1" dirty="0">
                 <a:solidFill>
                   <a:schemeClr val="accent1"/>
                 </a:solidFill>
@@ -26706,7 +26562,7 @@
               <a:t> </a:t>
             </a:r>
             <a:r>
-              <a:rPr lang="ko-KR" altLang="en-US" sz="2800" b="1" dirty="0" smtClean="0">
+              <a:rPr lang="ko-KR" altLang="en-US" sz="2800" b="1" dirty="0">
                 <a:solidFill>
                   <a:schemeClr val="accent1"/>
                 </a:solidFill>
@@ -26715,7 +26571,7 @@
               <a:t>변경하기</a:t>
             </a:r>
             <a:r>
-              <a:rPr lang="en-US" altLang="ko-KR" sz="2800" b="1" dirty="0" smtClean="0">
+              <a:rPr lang="en-US" altLang="ko-KR" sz="2800" b="1" dirty="0">
                 <a:solidFill>
                   <a:schemeClr val="accent1"/>
                 </a:solidFill>
@@ -26724,7 +26580,7 @@
               <a:t>]</a:t>
             </a:r>
             <a:r>
-              <a:rPr lang="en-US" altLang="ko-KR" sz="2800" dirty="0" smtClean="0">
+              <a:rPr lang="en-US" altLang="ko-KR" sz="2800" dirty="0">
                 <a:solidFill>
                   <a:schemeClr val="accent1"/>
                 </a:solidFill>
@@ -26733,22 +26589,13 @@
               <a:t> </a:t>
             </a:r>
             <a:r>
-              <a:rPr lang="ko-KR" altLang="en-US" sz="2800" dirty="0" smtClean="0">
+              <a:rPr lang="ko-KR" altLang="en-US" sz="2800" dirty="0">
                 <a:solidFill>
                   <a:srgbClr val="212529"/>
                 </a:solidFill>
                 <a:latin typeface="+mn-ea"/>
               </a:rPr>
-              <a:t> </a:t>
-            </a:r>
-            <a:r>
-              <a:rPr lang="ko-KR" altLang="en-US" sz="2800" dirty="0">
-                <a:solidFill>
-                  <a:srgbClr val="212529"/>
-                </a:solidFill>
-                <a:latin typeface="+mn-ea"/>
-              </a:rPr>
-              <a:t>진행</a:t>
+              <a:t> 진행</a:t>
             </a:r>
           </a:p>
         </p:txBody>
@@ -28460,7 +28307,7 @@
               <a:t>  </a:t>
             </a:r>
             <a:r>
-              <a:rPr lang="ko-KR" altLang="en-US" sz="5400" smtClean="0">
+              <a:rPr lang="ko-KR" altLang="en-US" sz="5400">
                 <a:solidFill>
                   <a:srgbClr val="FF0000"/>
                 </a:solidFill>
@@ -28469,7 +28316,7 @@
               <a:t>차이</a:t>
             </a:r>
             <a:r>
-              <a:rPr lang="en-US" altLang="ko-KR" sz="5400" smtClean="0">
+              <a:rPr lang="en-US" altLang="ko-KR" sz="5400">
                 <a:effectLst/>
               </a:rPr>
               <a:t>?</a:t>
@@ -29240,7 +29087,7 @@
               <a:t> </a:t>
             </a:r>
             <a:r>
-              <a:rPr lang="ko-KR" altLang="en-US" sz="5400" dirty="0" smtClean="0">
+              <a:rPr lang="ko-KR" altLang="en-US" sz="5400" dirty="0">
                 <a:solidFill>
                   <a:srgbClr val="FF0000"/>
                 </a:solidFill>
@@ -29249,7 +29096,7 @@
               <a:t>차이</a:t>
             </a:r>
             <a:r>
-              <a:rPr lang="en-US" altLang="ko-KR" sz="5400" dirty="0" smtClean="0">
+              <a:rPr lang="en-US" altLang="ko-KR" sz="5400" dirty="0">
                 <a:effectLst/>
               </a:rPr>
               <a:t>?</a:t>
@@ -30449,26 +30296,18 @@
                   <a:srgbClr val="6EC173"/>
                 </a:solidFill>
               </a:rPr>
-              <a:t>. </a:t>
-            </a:r>
-            <a:r>
-              <a:rPr lang="en-US" altLang="ko-KR" dirty="0">
-                <a:solidFill>
-                  <a:srgbClr val="6EC173"/>
-                </a:solidFill>
-              </a:rPr>
+              <a:t>.  </a:t>
+            </a:r>
+            <a:r>
+              <a:rPr lang="en-US" altLang="ko-KR" dirty="0"/>
               <a:t> </a:t>
             </a:r>
             <a:r>
-              <a:rPr lang="en-US" altLang="ko-KR" dirty="0" smtClean="0"/>
-              <a:t> </a:t>
-            </a:r>
-            <a:r>
-              <a:rPr lang="ko-KR" altLang="en-US" dirty="0" smtClean="0"/>
+              <a:rPr lang="ko-KR" altLang="en-US" dirty="0"/>
               <a:t>아이스크림 베스트</a:t>
             </a:r>
             <a:r>
-              <a:rPr lang="en-US" altLang="ko-KR" dirty="0" smtClean="0"/>
+              <a:rPr lang="en-US" altLang="ko-KR" dirty="0"/>
               <a:t>9</a:t>
             </a:r>
             <a:endParaRPr lang="ko-KR" altLang="en-US" dirty="0"/>
@@ -30745,15 +30584,6 @@
               </a:rPr>
               <a:t>강의 클릭</a:t>
             </a:r>
-            <a:r>
-              <a:rPr lang="en-US" altLang="ko-KR" dirty="0">
-                <a:solidFill>
-                  <a:srgbClr val="212529"/>
-                </a:solidFill>
-                <a:latin typeface="+mn-ea"/>
-              </a:rPr>
-              <a:t/>
-            </a:r>
             <a:br>
               <a:rPr lang="en-US" altLang="ko-KR" dirty="0">
                 <a:solidFill>
@@ -30781,7 +30611,7 @@
               <a:t>➡ </a:t>
             </a:r>
             <a:r>
-              <a:rPr lang="en-US" altLang="ko-KR" sz="2800" b="1" dirty="0" smtClean="0">
+              <a:rPr lang="en-US" altLang="ko-KR" sz="2800" b="1" dirty="0">
                 <a:solidFill>
                   <a:srgbClr val="212529"/>
                 </a:solidFill>
@@ -30790,7 +30620,7 @@
               <a:t>[</a:t>
             </a:r>
             <a:r>
-              <a:rPr lang="en-US" altLang="ko-KR" sz="2800" b="1" dirty="0" err="1" smtClean="0">
+              <a:rPr lang="en-US" altLang="ko-KR" sz="2800" b="1" dirty="0" err="1">
                 <a:solidFill>
                   <a:srgbClr val="212529"/>
                 </a:solidFill>
@@ -30799,7 +30629,7 @@
               <a:t>Javascript</a:t>
             </a:r>
             <a:r>
-              <a:rPr lang="en-US" altLang="ko-KR" sz="2800" b="1" dirty="0" smtClean="0">
+              <a:rPr lang="en-US" altLang="ko-KR" sz="2800" b="1" dirty="0">
                 <a:solidFill>
                   <a:srgbClr val="212529"/>
                 </a:solidFill>
@@ -30808,7 +30638,7 @@
               <a:t> DOM </a:t>
             </a:r>
             <a:r>
-              <a:rPr lang="ko-KR" altLang="en-US" sz="2800" b="1" dirty="0" smtClean="0">
+              <a:rPr lang="ko-KR" altLang="en-US" sz="2800" b="1" dirty="0">
                 <a:solidFill>
                   <a:srgbClr val="212529"/>
                 </a:solidFill>
@@ -30817,7 +30647,7 @@
               <a:t>실습</a:t>
             </a:r>
             <a:r>
-              <a:rPr lang="en-US" altLang="ko-KR" sz="2800" b="1" dirty="0" smtClean="0">
+              <a:rPr lang="en-US" altLang="ko-KR" sz="2800" b="1" dirty="0">
                 <a:solidFill>
                   <a:srgbClr val="212529"/>
                 </a:solidFill>
@@ -30826,7 +30656,7 @@
               <a:t>(1)]</a:t>
             </a:r>
             <a:r>
-              <a:rPr lang="en-US" altLang="ko-KR" sz="2800" dirty="0" smtClean="0">
+              <a:rPr lang="en-US" altLang="ko-KR" sz="2800" dirty="0">
                 <a:solidFill>
                   <a:srgbClr val="212529"/>
                 </a:solidFill>
@@ -30862,7 +30692,7 @@
               <a:t>➡ </a:t>
             </a:r>
             <a:r>
-              <a:rPr lang="en-US" altLang="ko-KR" sz="2800" b="1" dirty="0" smtClean="0">
+              <a:rPr lang="en-US" altLang="ko-KR" sz="2800" b="1" dirty="0">
                 <a:solidFill>
                   <a:schemeClr val="accent1"/>
                 </a:solidFill>
@@ -30871,7 +30701,7 @@
               <a:t>[</a:t>
             </a:r>
             <a:r>
-              <a:rPr lang="ko-KR" altLang="en-US" sz="2800" b="1" dirty="0" err="1" smtClean="0">
+              <a:rPr lang="ko-KR" altLang="en-US" sz="2800" b="1" dirty="0" err="1">
                 <a:solidFill>
                   <a:schemeClr val="accent1"/>
                 </a:solidFill>
@@ -30886,70 +30716,43 @@
                 </a:solidFill>
                 <a:latin typeface="+mn-ea"/>
               </a:rPr>
-              <a:t>3</a:t>
-            </a:r>
-            <a:r>
-              <a:rPr lang="en-US" altLang="ko-KR" sz="2800" b="1" dirty="0" smtClean="0">
+              <a:t>3. </a:t>
+            </a:r>
+            <a:r>
+              <a:rPr lang="ko-KR" altLang="en-US" sz="2800" b="1" dirty="0">
                 <a:solidFill>
                   <a:schemeClr val="accent1"/>
                 </a:solidFill>
                 <a:latin typeface="+mn-ea"/>
               </a:rPr>
-              <a:t>. </a:t>
-            </a:r>
-            <a:r>
-              <a:rPr lang="ko-KR" altLang="en-US" sz="2800" b="1" dirty="0" smtClean="0">
+              <a:t>아이스크림 베스트</a:t>
+            </a:r>
+            <a:r>
+              <a:rPr lang="en-US" altLang="ko-KR" sz="2800" b="1" dirty="0">
                 <a:solidFill>
                   <a:schemeClr val="accent1"/>
                 </a:solidFill>
                 <a:latin typeface="+mn-ea"/>
               </a:rPr>
-              <a:t>아이스크림 베스트</a:t>
-            </a:r>
-            <a:r>
-              <a:rPr lang="en-US" altLang="ko-KR" sz="2800" b="1" dirty="0">
+              <a:t>9]</a:t>
+            </a:r>
+            <a:r>
+              <a:rPr lang="en-US" altLang="ko-KR" sz="2800" dirty="0">
                 <a:solidFill>
                   <a:schemeClr val="accent1"/>
                 </a:solidFill>
                 <a:latin typeface="+mn-ea"/>
               </a:rPr>
-              <a:t>9</a:t>
-            </a:r>
-            <a:r>
-              <a:rPr lang="en-US" altLang="ko-KR" sz="2800" b="1" dirty="0" smtClean="0">
-                <a:solidFill>
-                  <a:schemeClr val="accent1"/>
+              <a:t> </a:t>
+            </a:r>
+            <a:r>
+              <a:rPr lang="ko-KR" altLang="en-US" sz="2800" dirty="0">
+                <a:solidFill>
+                  <a:srgbClr val="212529"/>
                 </a:solidFill>
                 <a:latin typeface="+mn-ea"/>
               </a:rPr>
-              <a:t>]</a:t>
-            </a:r>
-            <a:r>
-              <a:rPr lang="en-US" altLang="ko-KR" sz="2800" dirty="0" smtClean="0">
-                <a:solidFill>
-                  <a:schemeClr val="accent1"/>
-                </a:solidFill>
-                <a:latin typeface="+mn-ea"/>
-              </a:rPr>
-              <a:t> </a:t>
-            </a:r>
-            <a:r>
-              <a:rPr lang="ko-KR" altLang="en-US" sz="2800" dirty="0" smtClean="0">
-                <a:solidFill>
-                  <a:srgbClr val="212529"/>
-                </a:solidFill>
-                <a:latin typeface="+mn-ea"/>
-              </a:rPr>
-              <a:t> </a:t>
-            </a:r>
-            <a:r>
-              <a:rPr lang="ko-KR" altLang="en-US" sz="2800" dirty="0">
-                <a:solidFill>
-                  <a:srgbClr val="212529"/>
-                </a:solidFill>
-                <a:latin typeface="+mn-ea"/>
-              </a:rPr>
-              <a:t>진행</a:t>
+              <a:t> 진행</a:t>
             </a:r>
           </a:p>
         </p:txBody>
@@ -31054,10 +30857,6 @@
               <a:rPr lang="ko-KR" altLang="en-US" sz="7200" dirty="0"/>
               <a:t>이벤트 </a:t>
             </a:r>
-            <a:r>
-              <a:rPr lang="en-US" altLang="ko-KR" sz="7200" dirty="0"/>
-              <a:t/>
-            </a:r>
             <a:br>
               <a:rPr lang="en-US" altLang="ko-KR" sz="7200" dirty="0"/>
             </a:br>
@@ -31545,7 +31344,7 @@
             </a:r>
           </a:p>
           <a:p>
-            <a:r>
+            <a:br>
               <a:rPr lang="en-US" altLang="ko-KR" b="0" dirty="0">
                 <a:solidFill>
                   <a:srgbClr val="D4D4D4"/>
@@ -31553,89 +31352,69 @@
                 <a:effectLst/>
                 <a:latin typeface="Consolas" panose="020B0609020204030204" pitchFamily="49" charset="0"/>
               </a:rPr>
-              <a:t/>
-            </a:r>
-            <a:br>
+            </a:br>
+            <a:r>
               <a:rPr lang="en-US" altLang="ko-KR" b="0" dirty="0">
                 <a:solidFill>
-                  <a:srgbClr val="D4D4D4"/>
+                  <a:srgbClr val="9CDCFE"/>
                 </a:solidFill>
                 <a:effectLst/>
                 <a:latin typeface="Consolas" panose="020B0609020204030204" pitchFamily="49" charset="0"/>
               </a:rPr>
-            </a:br>
+              <a:t>console</a:t>
+            </a:r>
             <a:r>
               <a:rPr lang="en-US" altLang="ko-KR" b="0" dirty="0">
                 <a:solidFill>
-                  <a:srgbClr val="9CDCFE"/>
+                  <a:srgbClr val="D4D4D4"/>
                 </a:solidFill>
                 <a:effectLst/>
                 <a:latin typeface="Consolas" panose="020B0609020204030204" pitchFamily="49" charset="0"/>
               </a:rPr>
-              <a:t>console</a:t>
+              <a:t>.</a:t>
             </a:r>
             <a:r>
               <a:rPr lang="en-US" altLang="ko-KR" b="0" dirty="0">
                 <a:solidFill>
-                  <a:srgbClr val="D4D4D4"/>
+                  <a:srgbClr val="DCDCAA"/>
                 </a:solidFill>
                 <a:effectLst/>
                 <a:latin typeface="Consolas" panose="020B0609020204030204" pitchFamily="49" charset="0"/>
               </a:rPr>
-              <a:t>.</a:t>
+              <a:t>log</a:t>
             </a:r>
             <a:r>
               <a:rPr lang="en-US" altLang="ko-KR" b="0" dirty="0">
                 <a:solidFill>
-                  <a:srgbClr val="DCDCAA"/>
+                  <a:srgbClr val="D4D4D4"/>
                 </a:solidFill>
                 <a:effectLst/>
                 <a:latin typeface="Consolas" panose="020B0609020204030204" pitchFamily="49" charset="0"/>
               </a:rPr>
-              <a:t>log</a:t>
-            </a:r>
-            <a:r>
-              <a:rPr lang="en-US" altLang="ko-KR" b="0" dirty="0">
-                <a:solidFill>
-                  <a:srgbClr val="D4D4D4"/>
+              <a:t>(</a:t>
+            </a:r>
+            <a:r>
+              <a:rPr lang="en-US" altLang="ko-KR" b="0" dirty="0" err="1">
+                <a:solidFill>
+                  <a:srgbClr val="9CDCFE"/>
                 </a:solidFill>
                 <a:effectLst/>
                 <a:latin typeface="Consolas" panose="020B0609020204030204" pitchFamily="49" charset="0"/>
               </a:rPr>
-              <a:t>(</a:t>
-            </a:r>
-            <a:r>
-              <a:rPr lang="en-US" altLang="ko-KR" b="0" dirty="0" err="1">
-                <a:solidFill>
-                  <a:srgbClr val="9CDCFE"/>
+              <a:t>boxEl</a:t>
+            </a:r>
+            <a:r>
+              <a:rPr lang="en-US" altLang="ko-KR" b="0" dirty="0">
+                <a:solidFill>
+                  <a:srgbClr val="D4D4D4"/>
                 </a:solidFill>
                 <a:effectLst/>
                 <a:latin typeface="Consolas" panose="020B0609020204030204" pitchFamily="49" charset="0"/>
               </a:rPr>
-              <a:t>boxEl</a:t>
-            </a:r>
-            <a:r>
-              <a:rPr lang="en-US" altLang="ko-KR" b="0" dirty="0">
-                <a:solidFill>
-                  <a:srgbClr val="D4D4D4"/>
-                </a:solidFill>
-                <a:effectLst/>
-                <a:latin typeface="Consolas" panose="020B0609020204030204" pitchFamily="49" charset="0"/>
-              </a:rPr>
               <a:t>);</a:t>
             </a:r>
           </a:p>
           <a:p>
-            <a:r>
-              <a:rPr lang="en-US" altLang="ko-KR" b="0" dirty="0">
-                <a:solidFill>
-                  <a:srgbClr val="D4D4D4"/>
-                </a:solidFill>
-                <a:effectLst/>
-                <a:latin typeface="Consolas" panose="020B0609020204030204" pitchFamily="49" charset="0"/>
-              </a:rPr>
-              <a:t/>
-            </a:r>
             <a:br>
               <a:rPr lang="en-US" altLang="ko-KR" b="0" dirty="0">
                 <a:solidFill>
@@ -33205,25 +32984,16 @@
                   <a:srgbClr val="6EC173"/>
                 </a:solidFill>
               </a:rPr>
-              <a:t>. </a:t>
-            </a:r>
-            <a:r>
-              <a:rPr lang="en-US" altLang="ko-KR" dirty="0">
-                <a:solidFill>
-                  <a:srgbClr val="6EC173"/>
-                </a:solidFill>
-              </a:rPr>
+              <a:t>.  </a:t>
+            </a:r>
+            <a:r>
+              <a:rPr lang="en-US" altLang="ko-KR" dirty="0"/>
               <a:t> </a:t>
             </a:r>
             <a:r>
-              <a:rPr lang="en-US" altLang="ko-KR" dirty="0" smtClean="0"/>
-              <a:t> </a:t>
-            </a:r>
-            <a:r>
-              <a:rPr lang="ko-KR" altLang="en-US" dirty="0" smtClean="0"/>
+              <a:rPr lang="ko-KR" altLang="en-US" dirty="0"/>
               <a:t>이벤트 다루기</a:t>
             </a:r>
-            <a:endParaRPr lang="ko-KR" altLang="en-US" dirty="0"/>
           </a:p>
         </p:txBody>
       </p:sp>
@@ -33497,15 +33267,6 @@
               </a:rPr>
               <a:t>강의 클릭</a:t>
             </a:r>
-            <a:r>
-              <a:rPr lang="en-US" altLang="ko-KR" dirty="0">
-                <a:solidFill>
-                  <a:srgbClr val="212529"/>
-                </a:solidFill>
-                <a:latin typeface="+mn-ea"/>
-              </a:rPr>
-              <a:t/>
-            </a:r>
             <a:br>
               <a:rPr lang="en-US" altLang="ko-KR" dirty="0">
                 <a:solidFill>
@@ -33533,7 +33294,7 @@
               <a:t>➡ </a:t>
             </a:r>
             <a:r>
-              <a:rPr lang="en-US" altLang="ko-KR" sz="2800" b="1" dirty="0" smtClean="0">
+              <a:rPr lang="en-US" altLang="ko-KR" sz="2800" b="1" dirty="0">
                 <a:solidFill>
                   <a:srgbClr val="212529"/>
                 </a:solidFill>
@@ -33542,7 +33303,7 @@
               <a:t>[</a:t>
             </a:r>
             <a:r>
-              <a:rPr lang="en-US" altLang="ko-KR" sz="2800" b="1" dirty="0" err="1" smtClean="0">
+              <a:rPr lang="en-US" altLang="ko-KR" sz="2800" b="1" dirty="0" err="1">
                 <a:solidFill>
                   <a:srgbClr val="212529"/>
                 </a:solidFill>
@@ -33551,7 +33312,7 @@
               <a:t>Javascript</a:t>
             </a:r>
             <a:r>
-              <a:rPr lang="en-US" altLang="ko-KR" sz="2800" b="1" dirty="0" smtClean="0">
+              <a:rPr lang="en-US" altLang="ko-KR" sz="2800" b="1" dirty="0">
                 <a:solidFill>
                   <a:srgbClr val="212529"/>
                 </a:solidFill>
@@ -33560,7 +33321,7 @@
               <a:t> DOM </a:t>
             </a:r>
             <a:r>
-              <a:rPr lang="ko-KR" altLang="en-US" sz="2800" b="1" dirty="0" smtClean="0">
+              <a:rPr lang="ko-KR" altLang="en-US" sz="2800" b="1" dirty="0">
                 <a:solidFill>
                   <a:srgbClr val="212529"/>
                 </a:solidFill>
@@ -33569,7 +33330,7 @@
               <a:t>실습</a:t>
             </a:r>
             <a:r>
-              <a:rPr lang="en-US" altLang="ko-KR" sz="2800" b="1" dirty="0" smtClean="0">
+              <a:rPr lang="en-US" altLang="ko-KR" sz="2800" b="1" dirty="0">
                 <a:solidFill>
                   <a:srgbClr val="212529"/>
                 </a:solidFill>
@@ -33578,7 +33339,7 @@
               <a:t>(2)]</a:t>
             </a:r>
             <a:r>
-              <a:rPr lang="en-US" altLang="ko-KR" sz="2800" dirty="0" smtClean="0">
+              <a:rPr lang="en-US" altLang="ko-KR" sz="2800" dirty="0">
                 <a:solidFill>
                   <a:srgbClr val="212529"/>
                 </a:solidFill>
@@ -33614,7 +33375,7 @@
               <a:t>➡ </a:t>
             </a:r>
             <a:r>
-              <a:rPr lang="en-US" altLang="ko-KR" sz="2800" b="1" dirty="0" smtClean="0">
+              <a:rPr lang="en-US" altLang="ko-KR" sz="2800" b="1" dirty="0">
                 <a:solidFill>
                   <a:schemeClr val="accent1"/>
                 </a:solidFill>
@@ -33623,7 +33384,7 @@
               <a:t>[</a:t>
             </a:r>
             <a:r>
-              <a:rPr lang="ko-KR" altLang="en-US" sz="2800" b="1" dirty="0" err="1" smtClean="0">
+              <a:rPr lang="ko-KR" altLang="en-US" sz="2800" b="1" dirty="0" err="1">
                 <a:solidFill>
                   <a:schemeClr val="accent1"/>
                 </a:solidFill>
@@ -33632,7 +33393,7 @@
               <a:t>실습문제</a:t>
             </a:r>
             <a:r>
-              <a:rPr lang="en-US" altLang="ko-KR" sz="2800" b="1" dirty="0" smtClean="0">
+              <a:rPr lang="en-US" altLang="ko-KR" sz="2800" b="1" dirty="0">
                 <a:solidFill>
                   <a:schemeClr val="accent1"/>
                 </a:solidFill>
@@ -33641,7 +33402,7 @@
               <a:t>1. </a:t>
             </a:r>
             <a:r>
-              <a:rPr lang="ko-KR" altLang="en-US" sz="2800" b="1" dirty="0" smtClean="0">
+              <a:rPr lang="ko-KR" altLang="en-US" sz="2800" b="1" dirty="0">
                 <a:solidFill>
                   <a:schemeClr val="accent1"/>
                 </a:solidFill>
@@ -33650,7 +33411,7 @@
               <a:t>랜덤 색상 </a:t>
             </a:r>
             <a:r>
-              <a:rPr lang="ko-KR" altLang="en-US" sz="2800" b="1" dirty="0" err="1" smtClean="0">
+              <a:rPr lang="ko-KR" altLang="en-US" sz="2800" b="1" dirty="0" err="1">
                 <a:solidFill>
                   <a:schemeClr val="accent1"/>
                 </a:solidFill>
@@ -33659,7 +33420,7 @@
               <a:t>생성기</a:t>
             </a:r>
             <a:r>
-              <a:rPr lang="en-US" altLang="ko-KR" sz="2800" b="1" dirty="0" smtClean="0">
+              <a:rPr lang="en-US" altLang="ko-KR" sz="2800" b="1" dirty="0">
                 <a:solidFill>
                   <a:schemeClr val="accent1"/>
                 </a:solidFill>
@@ -33668,7 +33429,7 @@
               <a:t>]</a:t>
             </a:r>
             <a:r>
-              <a:rPr lang="en-US" altLang="ko-KR" sz="2800" dirty="0" smtClean="0">
+              <a:rPr lang="en-US" altLang="ko-KR" sz="2800" dirty="0">
                 <a:solidFill>
                   <a:schemeClr val="accent1"/>
                 </a:solidFill>
@@ -33677,22 +33438,13 @@
               <a:t> </a:t>
             </a:r>
             <a:r>
-              <a:rPr lang="ko-KR" altLang="en-US" sz="2800" dirty="0" smtClean="0">
+              <a:rPr lang="ko-KR" altLang="en-US" sz="2800" dirty="0">
                 <a:solidFill>
                   <a:srgbClr val="212529"/>
                 </a:solidFill>
                 <a:latin typeface="+mn-ea"/>
               </a:rPr>
-              <a:t> </a:t>
-            </a:r>
-            <a:r>
-              <a:rPr lang="ko-KR" altLang="en-US" sz="2800" dirty="0">
-                <a:solidFill>
-                  <a:srgbClr val="212529"/>
-                </a:solidFill>
-                <a:latin typeface="+mn-ea"/>
-              </a:rPr>
-              <a:t>진행</a:t>
+              <a:t> 진행</a:t>
             </a:r>
           </a:p>
         </p:txBody>
@@ -33861,26 +33613,18 @@
                   <a:srgbClr val="6EC173"/>
                 </a:solidFill>
               </a:rPr>
-              <a:t>. </a:t>
-            </a:r>
-            <a:r>
-              <a:rPr lang="en-US" altLang="ko-KR" dirty="0">
-                <a:solidFill>
-                  <a:srgbClr val="6EC173"/>
-                </a:solidFill>
-              </a:rPr>
+              <a:t>.  </a:t>
+            </a:r>
+            <a:r>
+              <a:rPr lang="en-US" altLang="ko-KR" dirty="0"/>
               <a:t> </a:t>
             </a:r>
             <a:r>
-              <a:rPr lang="en-US" altLang="ko-KR" dirty="0" smtClean="0"/>
-              <a:t> </a:t>
-            </a:r>
-            <a:r>
-              <a:rPr lang="ko-KR" altLang="en-US" dirty="0" smtClean="0"/>
+              <a:rPr lang="ko-KR" altLang="en-US" dirty="0"/>
               <a:t>이벤트 다루기</a:t>
             </a:r>
             <a:r>
-              <a:rPr lang="en-US" altLang="ko-KR" dirty="0" smtClean="0"/>
+              <a:rPr lang="en-US" altLang="ko-KR" dirty="0"/>
               <a:t>(2)</a:t>
             </a:r>
             <a:endParaRPr lang="ko-KR" altLang="en-US" dirty="0"/>
@@ -34157,15 +33901,6 @@
               </a:rPr>
               <a:t>강의 클릭</a:t>
             </a:r>
-            <a:r>
-              <a:rPr lang="en-US" altLang="ko-KR" dirty="0">
-                <a:solidFill>
-                  <a:srgbClr val="212529"/>
-                </a:solidFill>
-                <a:latin typeface="+mn-ea"/>
-              </a:rPr>
-              <a:t/>
-            </a:r>
             <a:br>
               <a:rPr lang="en-US" altLang="ko-KR" dirty="0">
                 <a:solidFill>
@@ -34193,7 +33928,7 @@
               <a:t>➡ </a:t>
             </a:r>
             <a:r>
-              <a:rPr lang="en-US" altLang="ko-KR" sz="2800" b="1" dirty="0" smtClean="0">
+              <a:rPr lang="en-US" altLang="ko-KR" sz="2800" b="1" dirty="0">
                 <a:solidFill>
                   <a:srgbClr val="212529"/>
                 </a:solidFill>
@@ -34202,7 +33937,7 @@
               <a:t>[</a:t>
             </a:r>
             <a:r>
-              <a:rPr lang="en-US" altLang="ko-KR" sz="2800" b="1" dirty="0" err="1" smtClean="0">
+              <a:rPr lang="en-US" altLang="ko-KR" sz="2800" b="1" dirty="0" err="1">
                 <a:solidFill>
                   <a:srgbClr val="212529"/>
                 </a:solidFill>
@@ -34211,7 +33946,7 @@
               <a:t>Javascript</a:t>
             </a:r>
             <a:r>
-              <a:rPr lang="en-US" altLang="ko-KR" sz="2800" b="1" dirty="0" smtClean="0">
+              <a:rPr lang="en-US" altLang="ko-KR" sz="2800" b="1" dirty="0">
                 <a:solidFill>
                   <a:srgbClr val="212529"/>
                 </a:solidFill>
@@ -34220,7 +33955,7 @@
               <a:t> DOM </a:t>
             </a:r>
             <a:r>
-              <a:rPr lang="ko-KR" altLang="en-US" sz="2800" b="1" dirty="0" smtClean="0">
+              <a:rPr lang="ko-KR" altLang="en-US" sz="2800" b="1" dirty="0">
                 <a:solidFill>
                   <a:srgbClr val="212529"/>
                 </a:solidFill>
@@ -34229,7 +33964,7 @@
               <a:t>실습</a:t>
             </a:r>
             <a:r>
-              <a:rPr lang="en-US" altLang="ko-KR" sz="2800" b="1" dirty="0" smtClean="0">
+              <a:rPr lang="en-US" altLang="ko-KR" sz="2800" b="1" dirty="0">
                 <a:solidFill>
                   <a:srgbClr val="212529"/>
                 </a:solidFill>
@@ -34238,7 +33973,7 @@
               <a:t>(2)]</a:t>
             </a:r>
             <a:r>
-              <a:rPr lang="en-US" altLang="ko-KR" sz="2800" dirty="0" smtClean="0">
+              <a:rPr lang="en-US" altLang="ko-KR" sz="2800" dirty="0">
                 <a:solidFill>
                   <a:srgbClr val="212529"/>
                 </a:solidFill>
@@ -34274,7 +34009,7 @@
               <a:t>➡ </a:t>
             </a:r>
             <a:r>
-              <a:rPr lang="en-US" altLang="ko-KR" sz="2800" b="1" dirty="0" smtClean="0">
+              <a:rPr lang="en-US" altLang="ko-KR" sz="2800" b="1" dirty="0">
                 <a:solidFill>
                   <a:schemeClr val="accent1"/>
                 </a:solidFill>
@@ -34283,7 +34018,7 @@
               <a:t>[</a:t>
             </a:r>
             <a:r>
-              <a:rPr lang="ko-KR" altLang="en-US" sz="2800" b="1" dirty="0" err="1" smtClean="0">
+              <a:rPr lang="ko-KR" altLang="en-US" sz="2800" b="1" dirty="0" err="1">
                 <a:solidFill>
                   <a:schemeClr val="accent1"/>
                 </a:solidFill>
@@ -34292,67 +34027,49 @@
               <a:t>실습문제</a:t>
             </a:r>
             <a:r>
-              <a:rPr lang="en-US" altLang="ko-KR" sz="2800" b="1" dirty="0" smtClean="0">
+              <a:rPr lang="en-US" altLang="ko-KR" sz="2800" b="1" dirty="0">
                 <a:solidFill>
                   <a:schemeClr val="accent1"/>
                 </a:solidFill>
                 <a:latin typeface="+mn-ea"/>
               </a:rPr>
-              <a:t>2</a:t>
-            </a:r>
-            <a:r>
-              <a:rPr lang="en-US" altLang="ko-KR" sz="2800" b="1" dirty="0" smtClean="0">
+              <a:t>2. </a:t>
+            </a:r>
+            <a:r>
+              <a:rPr lang="ko-KR" altLang="en-US" sz="2800" b="1" dirty="0">
                 <a:solidFill>
                   <a:schemeClr val="accent1"/>
                 </a:solidFill>
                 <a:latin typeface="+mn-ea"/>
               </a:rPr>
-              <a:t>. </a:t>
-            </a:r>
-            <a:r>
-              <a:rPr lang="ko-KR" altLang="en-US" sz="2800" b="1" dirty="0" smtClean="0">
+              <a:t>댓글 등록하기</a:t>
+            </a:r>
+            <a:r>
+              <a:rPr lang="en-US" altLang="ko-KR" sz="2800" b="1" dirty="0">
                 <a:solidFill>
                   <a:schemeClr val="accent1"/>
                 </a:solidFill>
                 <a:latin typeface="+mn-ea"/>
               </a:rPr>
-              <a:t>댓글 등록하기</a:t>
-            </a:r>
-            <a:r>
-              <a:rPr lang="en-US" altLang="ko-KR" sz="2800" b="1" dirty="0" smtClean="0">
+              <a:t>]</a:t>
+            </a:r>
+            <a:r>
+              <a:rPr lang="en-US" altLang="ko-KR" sz="2800" dirty="0">
                 <a:solidFill>
                   <a:schemeClr val="accent1"/>
                 </a:solidFill>
                 <a:latin typeface="+mn-ea"/>
               </a:rPr>
-              <a:t>]</a:t>
-            </a:r>
-            <a:r>
-              <a:rPr lang="en-US" altLang="ko-KR" sz="2800" dirty="0" smtClean="0">
-                <a:solidFill>
-                  <a:schemeClr val="accent1"/>
+              <a:t> </a:t>
+            </a:r>
+            <a:r>
+              <a:rPr lang="ko-KR" altLang="en-US" sz="2800" dirty="0">
+                <a:solidFill>
+                  <a:srgbClr val="212529"/>
                 </a:solidFill>
                 <a:latin typeface="+mn-ea"/>
               </a:rPr>
-              <a:t> </a:t>
-            </a:r>
-            <a:r>
-              <a:rPr lang="ko-KR" altLang="en-US" sz="2800" dirty="0" smtClean="0">
-                <a:solidFill>
-                  <a:srgbClr val="212529"/>
-                </a:solidFill>
-                <a:latin typeface="+mn-ea"/>
-              </a:rPr>
-              <a:t> </a:t>
-            </a:r>
-            <a:r>
-              <a:rPr lang="ko-KR" altLang="en-US" sz="2800" dirty="0">
-                <a:solidFill>
-                  <a:srgbClr val="212529"/>
-                </a:solidFill>
-                <a:latin typeface="+mn-ea"/>
-              </a:rPr>
-              <a:t>진행</a:t>
+              <a:t> 진행</a:t>
             </a:r>
           </a:p>
         </p:txBody>
@@ -34521,26 +34238,18 @@
                   <a:srgbClr val="6EC173"/>
                 </a:solidFill>
               </a:rPr>
-              <a:t>. </a:t>
-            </a:r>
-            <a:r>
-              <a:rPr lang="en-US" altLang="ko-KR" dirty="0">
-                <a:solidFill>
-                  <a:srgbClr val="6EC173"/>
-                </a:solidFill>
-              </a:rPr>
+              <a:t>.  </a:t>
+            </a:r>
+            <a:r>
+              <a:rPr lang="en-US" altLang="ko-KR" dirty="0"/>
               <a:t> </a:t>
             </a:r>
             <a:r>
-              <a:rPr lang="en-US" altLang="ko-KR" dirty="0" smtClean="0"/>
-              <a:t> </a:t>
-            </a:r>
-            <a:r>
-              <a:rPr lang="ko-KR" altLang="en-US" dirty="0" smtClean="0"/>
+              <a:rPr lang="ko-KR" altLang="en-US" dirty="0"/>
               <a:t>이벤트 다루기</a:t>
             </a:r>
             <a:r>
-              <a:rPr lang="en-US" altLang="ko-KR" dirty="0" smtClean="0"/>
+              <a:rPr lang="en-US" altLang="ko-KR" dirty="0"/>
               <a:t>(3)</a:t>
             </a:r>
             <a:endParaRPr lang="ko-KR" altLang="en-US" dirty="0"/>
@@ -34817,15 +34526,6 @@
               </a:rPr>
               <a:t>강의 클릭</a:t>
             </a:r>
-            <a:r>
-              <a:rPr lang="en-US" altLang="ko-KR" dirty="0">
-                <a:solidFill>
-                  <a:srgbClr val="212529"/>
-                </a:solidFill>
-                <a:latin typeface="+mn-ea"/>
-              </a:rPr>
-              <a:t/>
-            </a:r>
             <a:br>
               <a:rPr lang="en-US" altLang="ko-KR" dirty="0">
                 <a:solidFill>
@@ -34853,7 +34553,7 @@
               <a:t>➡ </a:t>
             </a:r>
             <a:r>
-              <a:rPr lang="en-US" altLang="ko-KR" sz="2800" b="1" dirty="0" smtClean="0">
+              <a:rPr lang="en-US" altLang="ko-KR" sz="2800" b="1" dirty="0">
                 <a:solidFill>
                   <a:srgbClr val="212529"/>
                 </a:solidFill>
@@ -34862,7 +34562,7 @@
               <a:t>[</a:t>
             </a:r>
             <a:r>
-              <a:rPr lang="en-US" altLang="ko-KR" sz="2800" b="1" dirty="0" err="1" smtClean="0">
+              <a:rPr lang="en-US" altLang="ko-KR" sz="2800" b="1" dirty="0" err="1">
                 <a:solidFill>
                   <a:srgbClr val="212529"/>
                 </a:solidFill>
@@ -34871,7 +34571,7 @@
               <a:t>Javascript</a:t>
             </a:r>
             <a:r>
-              <a:rPr lang="en-US" altLang="ko-KR" sz="2800" b="1" dirty="0" smtClean="0">
+              <a:rPr lang="en-US" altLang="ko-KR" sz="2800" b="1" dirty="0">
                 <a:solidFill>
                   <a:srgbClr val="212529"/>
                 </a:solidFill>
@@ -34880,7 +34580,7 @@
               <a:t> DOM </a:t>
             </a:r>
             <a:r>
-              <a:rPr lang="ko-KR" altLang="en-US" sz="2800" b="1" dirty="0" smtClean="0">
+              <a:rPr lang="ko-KR" altLang="en-US" sz="2800" b="1" dirty="0">
                 <a:solidFill>
                   <a:srgbClr val="212529"/>
                 </a:solidFill>
@@ -34889,7 +34589,7 @@
               <a:t>실습</a:t>
             </a:r>
             <a:r>
-              <a:rPr lang="en-US" altLang="ko-KR" sz="2800" b="1" dirty="0" smtClean="0">
+              <a:rPr lang="en-US" altLang="ko-KR" sz="2800" b="1" dirty="0">
                 <a:solidFill>
                   <a:srgbClr val="212529"/>
                 </a:solidFill>
@@ -34898,7 +34598,7 @@
               <a:t>(2)]</a:t>
             </a:r>
             <a:r>
-              <a:rPr lang="en-US" altLang="ko-KR" sz="2800" dirty="0" smtClean="0">
+              <a:rPr lang="en-US" altLang="ko-KR" sz="2800" dirty="0">
                 <a:solidFill>
                   <a:srgbClr val="212529"/>
                 </a:solidFill>
@@ -34934,7 +34634,7 @@
               <a:t>➡ </a:t>
             </a:r>
             <a:r>
-              <a:rPr lang="en-US" altLang="ko-KR" sz="2800" b="1" dirty="0" smtClean="0">
+              <a:rPr lang="en-US" altLang="ko-KR" sz="2800" b="1" dirty="0">
                 <a:solidFill>
                   <a:schemeClr val="accent1"/>
                 </a:solidFill>
@@ -34943,7 +34643,7 @@
               <a:t>[</a:t>
             </a:r>
             <a:r>
-              <a:rPr lang="ko-KR" altLang="en-US" sz="2800" b="1" dirty="0" err="1" smtClean="0">
+              <a:rPr lang="ko-KR" altLang="en-US" sz="2800" b="1" dirty="0" err="1">
                 <a:solidFill>
                   <a:schemeClr val="accent1"/>
                 </a:solidFill>
@@ -34958,61 +34658,43 @@
                 </a:solidFill>
                 <a:latin typeface="+mn-ea"/>
               </a:rPr>
-              <a:t>3</a:t>
-            </a:r>
-            <a:r>
-              <a:rPr lang="en-US" altLang="ko-KR" sz="2800" b="1" dirty="0" smtClean="0">
+              <a:t>3. </a:t>
+            </a:r>
+            <a:r>
+              <a:rPr lang="ko-KR" altLang="en-US" sz="2800" b="1" dirty="0">
                 <a:solidFill>
                   <a:schemeClr val="accent1"/>
                 </a:solidFill>
                 <a:latin typeface="+mn-ea"/>
               </a:rPr>
-              <a:t>. </a:t>
-            </a:r>
-            <a:r>
-              <a:rPr lang="ko-KR" altLang="en-US" sz="2800" b="1" dirty="0" smtClean="0">
+              <a:t>계산기 만들기</a:t>
+            </a:r>
+            <a:r>
+              <a:rPr lang="en-US" altLang="ko-KR" sz="2800" b="1" dirty="0">
                 <a:solidFill>
                   <a:schemeClr val="accent1"/>
                 </a:solidFill>
                 <a:latin typeface="+mn-ea"/>
               </a:rPr>
-              <a:t>계산기 만들기</a:t>
-            </a:r>
-            <a:r>
-              <a:rPr lang="en-US" altLang="ko-KR" sz="2800" b="1" dirty="0" smtClean="0">
+              <a:t>]</a:t>
+            </a:r>
+            <a:r>
+              <a:rPr lang="en-US" altLang="ko-KR" sz="2800" dirty="0">
                 <a:solidFill>
                   <a:schemeClr val="accent1"/>
                 </a:solidFill>
                 <a:latin typeface="+mn-ea"/>
               </a:rPr>
-              <a:t>]</a:t>
-            </a:r>
-            <a:r>
-              <a:rPr lang="en-US" altLang="ko-KR" sz="2800" dirty="0" smtClean="0">
-                <a:solidFill>
-                  <a:schemeClr val="accent1"/>
+              <a:t> </a:t>
+            </a:r>
+            <a:r>
+              <a:rPr lang="ko-KR" altLang="en-US" sz="2800" dirty="0">
+                <a:solidFill>
+                  <a:srgbClr val="212529"/>
                 </a:solidFill>
                 <a:latin typeface="+mn-ea"/>
               </a:rPr>
-              <a:t> </a:t>
-            </a:r>
-            <a:r>
-              <a:rPr lang="ko-KR" altLang="en-US" sz="2800" dirty="0" smtClean="0">
-                <a:solidFill>
-                  <a:srgbClr val="212529"/>
-                </a:solidFill>
-                <a:latin typeface="+mn-ea"/>
-              </a:rPr>
-              <a:t> </a:t>
-            </a:r>
-            <a:r>
-              <a:rPr lang="ko-KR" altLang="en-US" sz="2800" dirty="0">
-                <a:solidFill>
-                  <a:srgbClr val="212529"/>
-                </a:solidFill>
-                <a:latin typeface="+mn-ea"/>
-              </a:rPr>
-              <a:t>진행</a:t>
+              <a:t> 진행</a:t>
             </a:r>
           </a:p>
         </p:txBody>
@@ -35181,26 +34863,18 @@
                   <a:srgbClr val="6EC173"/>
                 </a:solidFill>
               </a:rPr>
-              <a:t>. </a:t>
-            </a:r>
-            <a:r>
-              <a:rPr lang="en-US" altLang="ko-KR" dirty="0">
-                <a:solidFill>
-                  <a:srgbClr val="6EC173"/>
-                </a:solidFill>
-              </a:rPr>
+              <a:t>.  </a:t>
+            </a:r>
+            <a:r>
+              <a:rPr lang="en-US" altLang="ko-KR" dirty="0"/>
               <a:t> </a:t>
             </a:r>
             <a:r>
-              <a:rPr lang="en-US" altLang="ko-KR" dirty="0" smtClean="0"/>
-              <a:t> </a:t>
-            </a:r>
-            <a:r>
-              <a:rPr lang="ko-KR" altLang="en-US" dirty="0" smtClean="0"/>
+              <a:rPr lang="ko-KR" altLang="en-US" dirty="0"/>
               <a:t>이벤트 다루기</a:t>
             </a:r>
             <a:r>
-              <a:rPr lang="en-US" altLang="ko-KR" dirty="0" smtClean="0"/>
+              <a:rPr lang="en-US" altLang="ko-KR" dirty="0"/>
               <a:t>(4)</a:t>
             </a:r>
             <a:endParaRPr lang="ko-KR" altLang="en-US" dirty="0"/>
@@ -35477,15 +35151,6 @@
               </a:rPr>
               <a:t>강의 클릭</a:t>
             </a:r>
-            <a:r>
-              <a:rPr lang="en-US" altLang="ko-KR" dirty="0">
-                <a:solidFill>
-                  <a:srgbClr val="212529"/>
-                </a:solidFill>
-                <a:latin typeface="+mn-ea"/>
-              </a:rPr>
-              <a:t/>
-            </a:r>
             <a:br>
               <a:rPr lang="en-US" altLang="ko-KR" dirty="0">
                 <a:solidFill>
@@ -35513,7 +35178,7 @@
               <a:t>➡ </a:t>
             </a:r>
             <a:r>
-              <a:rPr lang="en-US" altLang="ko-KR" sz="2800" b="1" dirty="0" smtClean="0">
+              <a:rPr lang="en-US" altLang="ko-KR" sz="2800" b="1" dirty="0">
                 <a:solidFill>
                   <a:srgbClr val="212529"/>
                 </a:solidFill>
@@ -35522,7 +35187,7 @@
               <a:t>[</a:t>
             </a:r>
             <a:r>
-              <a:rPr lang="en-US" altLang="ko-KR" sz="2800" b="1" dirty="0" err="1" smtClean="0">
+              <a:rPr lang="en-US" altLang="ko-KR" sz="2800" b="1" dirty="0" err="1">
                 <a:solidFill>
                   <a:srgbClr val="212529"/>
                 </a:solidFill>
@@ -35531,7 +35196,7 @@
               <a:t>Javascript</a:t>
             </a:r>
             <a:r>
-              <a:rPr lang="en-US" altLang="ko-KR" sz="2800" b="1" dirty="0" smtClean="0">
+              <a:rPr lang="en-US" altLang="ko-KR" sz="2800" b="1" dirty="0">
                 <a:solidFill>
                   <a:srgbClr val="212529"/>
                 </a:solidFill>
@@ -35540,7 +35205,7 @@
               <a:t> DOM </a:t>
             </a:r>
             <a:r>
-              <a:rPr lang="ko-KR" altLang="en-US" sz="2800" b="1" dirty="0" smtClean="0">
+              <a:rPr lang="ko-KR" altLang="en-US" sz="2800" b="1" dirty="0">
                 <a:solidFill>
                   <a:srgbClr val="212529"/>
                 </a:solidFill>
@@ -35549,7 +35214,7 @@
               <a:t>실습</a:t>
             </a:r>
             <a:r>
-              <a:rPr lang="en-US" altLang="ko-KR" sz="2800" b="1" dirty="0" smtClean="0">
+              <a:rPr lang="en-US" altLang="ko-KR" sz="2800" b="1" dirty="0">
                 <a:solidFill>
                   <a:srgbClr val="212529"/>
                 </a:solidFill>
@@ -35558,7 +35223,7 @@
               <a:t>(2)]</a:t>
             </a:r>
             <a:r>
-              <a:rPr lang="en-US" altLang="ko-KR" sz="2800" dirty="0" smtClean="0">
+              <a:rPr lang="en-US" altLang="ko-KR" sz="2800" dirty="0">
                 <a:solidFill>
                   <a:srgbClr val="212529"/>
                 </a:solidFill>
@@ -35594,7 +35259,7 @@
               <a:t>➡ </a:t>
             </a:r>
             <a:r>
-              <a:rPr lang="en-US" altLang="ko-KR" sz="2800" b="1" dirty="0" smtClean="0">
+              <a:rPr lang="en-US" altLang="ko-KR" sz="2800" b="1" dirty="0">
                 <a:solidFill>
                   <a:schemeClr val="accent1"/>
                 </a:solidFill>
@@ -35603,7 +35268,7 @@
               <a:t>[</a:t>
             </a:r>
             <a:r>
-              <a:rPr lang="ko-KR" altLang="en-US" sz="2800" b="1" dirty="0" err="1" smtClean="0">
+              <a:rPr lang="ko-KR" altLang="en-US" sz="2800" b="1" dirty="0" err="1">
                 <a:solidFill>
                   <a:schemeClr val="accent1"/>
                 </a:solidFill>
@@ -35618,61 +35283,43 @@
                 </a:solidFill>
                 <a:latin typeface="+mn-ea"/>
               </a:rPr>
-              <a:t>4</a:t>
-            </a:r>
-            <a:r>
-              <a:rPr lang="en-US" altLang="ko-KR" sz="2800" b="1" dirty="0" smtClean="0">
+              <a:t>4. </a:t>
+            </a:r>
+            <a:r>
+              <a:rPr lang="ko-KR" altLang="en-US" sz="2800" b="1" dirty="0">
                 <a:solidFill>
                   <a:schemeClr val="accent1"/>
                 </a:solidFill>
                 <a:latin typeface="+mn-ea"/>
               </a:rPr>
-              <a:t>. </a:t>
-            </a:r>
-            <a:r>
-              <a:rPr lang="ko-KR" altLang="en-US" sz="2800" b="1" dirty="0" smtClean="0">
+              <a:t>방명록 등록하기</a:t>
+            </a:r>
+            <a:r>
+              <a:rPr lang="en-US" altLang="ko-KR" sz="2800" b="1" dirty="0">
                 <a:solidFill>
                   <a:schemeClr val="accent1"/>
                 </a:solidFill>
                 <a:latin typeface="+mn-ea"/>
               </a:rPr>
-              <a:t>방명록 등록하기</a:t>
-            </a:r>
-            <a:r>
-              <a:rPr lang="en-US" altLang="ko-KR" sz="2800" b="1" dirty="0" smtClean="0">
+              <a:t>]</a:t>
+            </a:r>
+            <a:r>
+              <a:rPr lang="en-US" altLang="ko-KR" sz="2800" dirty="0">
                 <a:solidFill>
                   <a:schemeClr val="accent1"/>
                 </a:solidFill>
                 <a:latin typeface="+mn-ea"/>
               </a:rPr>
-              <a:t>]</a:t>
-            </a:r>
-            <a:r>
-              <a:rPr lang="en-US" altLang="ko-KR" sz="2800" dirty="0" smtClean="0">
-                <a:solidFill>
-                  <a:schemeClr val="accent1"/>
+              <a:t> </a:t>
+            </a:r>
+            <a:r>
+              <a:rPr lang="ko-KR" altLang="en-US" sz="2800" dirty="0">
+                <a:solidFill>
+                  <a:srgbClr val="212529"/>
                 </a:solidFill>
                 <a:latin typeface="+mn-ea"/>
               </a:rPr>
-              <a:t> </a:t>
-            </a:r>
-            <a:r>
-              <a:rPr lang="ko-KR" altLang="en-US" sz="2800" dirty="0" smtClean="0">
-                <a:solidFill>
-                  <a:srgbClr val="212529"/>
-                </a:solidFill>
-                <a:latin typeface="+mn-ea"/>
-              </a:rPr>
-              <a:t> </a:t>
-            </a:r>
-            <a:r>
-              <a:rPr lang="ko-KR" altLang="en-US" sz="2800" dirty="0">
-                <a:solidFill>
-                  <a:srgbClr val="212529"/>
-                </a:solidFill>
-                <a:latin typeface="+mn-ea"/>
-              </a:rPr>
-              <a:t>진행</a:t>
+              <a:t> 진행</a:t>
             </a:r>
           </a:p>
         </p:txBody>

</xml_diff>

<commit_message>
ppt 복구 - 션
</commit_message>
<xml_diff>
--- a/material/[SeSAC_YDP_6] 04_5_Javascript_표준객체,DOM.pptx
+++ b/material/[SeSAC_YDP_6] 04_5_Javascript_표준객체,DOM.pptx
@@ -255,7 +255,7 @@
           <a:p>
             <a:fld id="{2EF3F159-7250-4DD4-91C2-13B35D56E1AF}" type="datetimeFigureOut">
               <a:rPr lang="ko-KR" altLang="en-US" smtClean="0"/>
-              <a:t>2024-06-10</a:t>
+              <a:t>2024-06-05</a:t>
             </a:fld>
             <a:endParaRPr lang="ko-KR" altLang="en-US"/>
           </a:p>
@@ -13086,158 +13086,9 @@
           <a:chExt cx="0" cy="0"/>
         </a:xfrm>
       </p:grpSpPr>
-      <p:sp>
-        <p:nvSpPr>
-          <p:cNvPr id="8" name="내용 개체 틀 2">
-            <a:extLst>
-              <a:ext uri="{FF2B5EF4-FFF2-40B4-BE49-F238E27FC236}">
-                <a16:creationId xmlns:a16="http://schemas.microsoft.com/office/drawing/2014/main" id="{1D6B0722-9480-BB35-73CF-93B49F6C5FF8}"/>
-              </a:ext>
-            </a:extLst>
-          </p:cNvPr>
-          <p:cNvSpPr>
-            <a:spLocks noGrp="1"/>
-          </p:cNvSpPr>
-          <p:nvPr>
-            <p:ph idx="1"/>
-          </p:nvPr>
-        </p:nvSpPr>
-        <p:spPr>
-          <a:xfrm>
-            <a:off x="5921829" y="2411698"/>
-            <a:ext cx="4203700" cy="721058"/>
-          </a:xfrm>
-        </p:spPr>
-        <p:txBody>
-          <a:bodyPr/>
-          <a:lstStyle/>
-          <a:p>
-            <a:pPr marL="0" indent="0">
-              <a:buNone/>
-            </a:pPr>
-            <a:r>
-              <a:rPr lang="ko-KR" altLang="en-US" dirty="0"/>
-              <a:t>키</a:t>
-            </a:r>
-            <a:r>
-              <a:rPr lang="en-US" altLang="ko-KR" dirty="0"/>
-              <a:t>-</a:t>
-            </a:r>
-            <a:r>
-              <a:rPr lang="ko-KR" altLang="en-US" dirty="0"/>
-              <a:t>값 형태로 저장</a:t>
-            </a:r>
-          </a:p>
-        </p:txBody>
-      </p:sp>
-      <p:sp>
-        <p:nvSpPr>
-          <p:cNvPr id="4" name="날짜 개체 틀 3">
-            <a:extLst>
-              <a:ext uri="{FF2B5EF4-FFF2-40B4-BE49-F238E27FC236}">
-                <a16:creationId xmlns:a16="http://schemas.microsoft.com/office/drawing/2014/main" id="{B2744276-5C6F-AD8B-9F61-9B2A520D86A2}"/>
-              </a:ext>
-            </a:extLst>
-          </p:cNvPr>
-          <p:cNvSpPr>
-            <a:spLocks noGrp="1"/>
-          </p:cNvSpPr>
-          <p:nvPr>
-            <p:ph type="dt" sz="half" idx="10"/>
-          </p:nvPr>
-        </p:nvSpPr>
-        <p:spPr/>
-        <p:txBody>
-          <a:bodyPr/>
-          <a:lstStyle/>
-          <a:p>
-            <a:fld id="{9D0404D9-6A52-4A99-9101-80BD6AA53C94}" type="datetime6">
-              <a:rPr lang="ko-KR" altLang="en-US" smtClean="0"/>
-              <a:t>2024년 6월</a:t>
-            </a:fld>
-            <a:endParaRPr lang="ko-KR" altLang="en-US"/>
-          </a:p>
-        </p:txBody>
-      </p:sp>
-      <p:sp>
-        <p:nvSpPr>
-          <p:cNvPr id="5" name="슬라이드 번호 개체 틀 4">
-            <a:extLst>
-              <a:ext uri="{FF2B5EF4-FFF2-40B4-BE49-F238E27FC236}">
-                <a16:creationId xmlns:a16="http://schemas.microsoft.com/office/drawing/2014/main" id="{E12E7352-FB36-4681-B691-48A912BACDBE}"/>
-              </a:ext>
-            </a:extLst>
-          </p:cNvPr>
-          <p:cNvSpPr>
-            <a:spLocks noGrp="1"/>
-          </p:cNvSpPr>
-          <p:nvPr>
-            <p:ph type="sldNum" sz="quarter" idx="12"/>
-          </p:nvPr>
-        </p:nvSpPr>
-        <p:spPr/>
-        <p:txBody>
-          <a:bodyPr/>
-          <a:lstStyle/>
-          <a:p>
-            <a:fld id="{083A2CE0-18CD-4102-B738-4ACFF9E68BA4}" type="slidenum">
-              <a:rPr lang="ko-KR" altLang="en-US" smtClean="0"/>
-              <a:t>12</a:t>
-            </a:fld>
-            <a:endParaRPr lang="ko-KR" altLang="en-US"/>
-          </a:p>
-        </p:txBody>
-      </p:sp>
-      <p:sp>
-        <p:nvSpPr>
-          <p:cNvPr id="2" name="제목 1">
-            <a:extLst>
-              <a:ext uri="{FF2B5EF4-FFF2-40B4-BE49-F238E27FC236}">
-                <a16:creationId xmlns:a16="http://schemas.microsoft.com/office/drawing/2014/main" id="{4AB12D32-4144-5D6A-1E9C-7EB121AB397A}"/>
-              </a:ext>
-            </a:extLst>
-          </p:cNvPr>
-          <p:cNvSpPr>
-            <a:spLocks noGrp="1"/>
-          </p:cNvSpPr>
-          <p:nvPr>
-            <p:ph type="title"/>
-          </p:nvPr>
-        </p:nvSpPr>
-        <p:spPr/>
-        <p:txBody>
-          <a:bodyPr/>
-          <a:lstStyle/>
-          <a:p>
-            <a:r>
-              <a:rPr lang="en-US" altLang="ko-KR" dirty="0"/>
-              <a:t>Object</a:t>
-            </a:r>
-            <a:r>
-              <a:rPr lang="ko-KR" altLang="en-US" dirty="0"/>
-              <a:t> 자료형 </a:t>
-            </a:r>
-            <a:r>
-              <a:rPr lang="en-US" altLang="ko-KR" dirty="0"/>
-              <a:t>- </a:t>
-            </a:r>
-            <a:r>
-              <a:rPr lang="ko-KR" altLang="en-US" dirty="0" err="1"/>
-              <a:t>딕셔너리</a:t>
-            </a:r>
-            <a:endParaRPr lang="ko-KR" altLang="en-US" dirty="0"/>
-          </a:p>
-        </p:txBody>
-      </p:sp>
       <p:pic>
         <p:nvPicPr>
-          <p:cNvPr id="7" name="그림 6">
-            <a:extLst>
-              <a:ext uri="{FF2B5EF4-FFF2-40B4-BE49-F238E27FC236}">
-                <a16:creationId xmlns:a16="http://schemas.microsoft.com/office/drawing/2014/main" id="{F97B2092-7319-43BF-4B4D-0C4C6153717F}"/>
-              </a:ext>
-            </a:extLst>
-          </p:cNvPr>
+          <p:cNvPr id="3" name="그림 2"/>
           <p:cNvPicPr>
             <a:picLocks noChangeAspect="1"/>
           </p:cNvPicPr>
@@ -13251,14 +13102,157 @@
         </p:blipFill>
         <p:spPr>
           <a:xfrm>
-            <a:off x="1158648" y="1758043"/>
-            <a:ext cx="4853140" cy="3549311"/>
+            <a:off x="1684412" y="1790700"/>
+            <a:ext cx="8340576" cy="3416300"/>
           </a:xfrm>
           <a:prstGeom prst="rect">
             <a:avLst/>
           </a:prstGeom>
         </p:spPr>
       </p:pic>
+      <p:sp>
+        <p:nvSpPr>
+          <p:cNvPr id="8" name="내용 개체 틀 2">
+            <a:extLst>
+              <a:ext uri="{FF2B5EF4-FFF2-40B4-BE49-F238E27FC236}">
+                <a16:creationId xmlns:a16="http://schemas.microsoft.com/office/drawing/2014/main" id="{1D6B0722-9480-BB35-73CF-93B49F6C5FF8}"/>
+              </a:ext>
+            </a:extLst>
+          </p:cNvPr>
+          <p:cNvSpPr>
+            <a:spLocks noGrp="1"/>
+          </p:cNvSpPr>
+          <p:nvPr>
+            <p:ph idx="1"/>
+          </p:nvPr>
+        </p:nvSpPr>
+        <p:spPr>
+          <a:xfrm>
+            <a:off x="5562600" y="2477398"/>
+            <a:ext cx="4203700" cy="721058"/>
+          </a:xfrm>
+        </p:spPr>
+        <p:txBody>
+          <a:bodyPr/>
+          <a:lstStyle/>
+          <a:p>
+            <a:pPr marL="0" indent="0">
+              <a:buNone/>
+            </a:pPr>
+            <a:r>
+              <a:rPr lang="ko-KR" altLang="en-US" dirty="0"/>
+              <a:t>키</a:t>
+            </a:r>
+            <a:r>
+              <a:rPr lang="en-US" altLang="ko-KR" dirty="0"/>
+              <a:t>-</a:t>
+            </a:r>
+            <a:r>
+              <a:rPr lang="ko-KR" altLang="en-US" dirty="0"/>
+              <a:t>값 형태로 저장</a:t>
+            </a:r>
+          </a:p>
+        </p:txBody>
+      </p:sp>
+      <p:sp>
+        <p:nvSpPr>
+          <p:cNvPr id="4" name="날짜 개체 틀 3">
+            <a:extLst>
+              <a:ext uri="{FF2B5EF4-FFF2-40B4-BE49-F238E27FC236}">
+                <a16:creationId xmlns:a16="http://schemas.microsoft.com/office/drawing/2014/main" id="{B2744276-5C6F-AD8B-9F61-9B2A520D86A2}"/>
+              </a:ext>
+            </a:extLst>
+          </p:cNvPr>
+          <p:cNvSpPr>
+            <a:spLocks noGrp="1"/>
+          </p:cNvSpPr>
+          <p:nvPr>
+            <p:ph type="dt" sz="half" idx="10"/>
+          </p:nvPr>
+        </p:nvSpPr>
+        <p:spPr/>
+        <p:txBody>
+          <a:bodyPr/>
+          <a:lstStyle/>
+          <a:p>
+            <a:fld id="{9D0404D9-6A52-4A99-9101-80BD6AA53C94}" type="datetime6">
+              <a:rPr lang="ko-KR" altLang="en-US" smtClean="0"/>
+              <a:t>2024년 6월</a:t>
+            </a:fld>
+            <a:endParaRPr lang="ko-KR" altLang="en-US"/>
+          </a:p>
+        </p:txBody>
+      </p:sp>
+      <p:sp>
+        <p:nvSpPr>
+          <p:cNvPr id="5" name="슬라이드 번호 개체 틀 4">
+            <a:extLst>
+              <a:ext uri="{FF2B5EF4-FFF2-40B4-BE49-F238E27FC236}">
+                <a16:creationId xmlns:a16="http://schemas.microsoft.com/office/drawing/2014/main" id="{E12E7352-FB36-4681-B691-48A912BACDBE}"/>
+              </a:ext>
+            </a:extLst>
+          </p:cNvPr>
+          <p:cNvSpPr>
+            <a:spLocks noGrp="1"/>
+          </p:cNvSpPr>
+          <p:nvPr>
+            <p:ph type="sldNum" sz="quarter" idx="12"/>
+          </p:nvPr>
+        </p:nvSpPr>
+        <p:spPr/>
+        <p:txBody>
+          <a:bodyPr/>
+          <a:lstStyle/>
+          <a:p>
+            <a:fld id="{083A2CE0-18CD-4102-B738-4ACFF9E68BA4}" type="slidenum">
+              <a:rPr lang="ko-KR" altLang="en-US" smtClean="0"/>
+              <a:t>12</a:t>
+            </a:fld>
+            <a:endParaRPr lang="ko-KR" altLang="en-US"/>
+          </a:p>
+        </p:txBody>
+      </p:sp>
+      <p:sp>
+        <p:nvSpPr>
+          <p:cNvPr id="2" name="제목 1">
+            <a:extLst>
+              <a:ext uri="{FF2B5EF4-FFF2-40B4-BE49-F238E27FC236}">
+                <a16:creationId xmlns:a16="http://schemas.microsoft.com/office/drawing/2014/main" id="{4AB12D32-4144-5D6A-1E9C-7EB121AB397A}"/>
+              </a:ext>
+            </a:extLst>
+          </p:cNvPr>
+          <p:cNvSpPr>
+            <a:spLocks noGrp="1"/>
+          </p:cNvSpPr>
+          <p:nvPr>
+            <p:ph type="title"/>
+          </p:nvPr>
+        </p:nvSpPr>
+        <p:spPr/>
+        <p:txBody>
+          <a:bodyPr/>
+          <a:lstStyle/>
+          <a:p>
+            <a:r>
+              <a:rPr lang="en-US" altLang="ko-KR" dirty="0"/>
+              <a:t>Object</a:t>
+            </a:r>
+            <a:r>
+              <a:rPr lang="ko-KR" altLang="en-US" dirty="0"/>
+              <a:t> 자료형 </a:t>
+            </a:r>
+            <a:r>
+              <a:rPr lang="en-US" altLang="ko-KR" dirty="0"/>
+              <a:t>- </a:t>
+            </a:r>
+            <a:r>
+              <a:rPr lang="ko-KR" altLang="en-US" dirty="0" err="1"/>
+              <a:t>딕셔너리</a:t>
+            </a:r>
+            <a:endParaRPr lang="ko-KR" altLang="en-US" dirty="0"/>
+          </a:p>
+        </p:txBody>
+      </p:sp>
     </p:spTree>
     <p:extLst>
       <p:ext uri="{BB962C8B-B14F-4D97-AF65-F5344CB8AC3E}">
@@ -15194,7 +15188,7 @@
           <a:p>
             <a:fld id="{0F78D9C4-20C1-4B15-A116-16DC77AD9A1E}" type="datetime1">
               <a:rPr lang="ko-KR" altLang="en-US" smtClean="0"/>
-              <a:t>2024-06-10</a:t>
+              <a:t>2024-06-05</a:t>
             </a:fld>
             <a:endParaRPr lang="ko-KR" altLang="en-US"/>
           </a:p>
@@ -15954,7 +15948,7 @@
           <a:p>
             <a:fld id="{0F78D9C4-20C1-4B15-A116-16DC77AD9A1E}" type="datetime1">
               <a:rPr lang="ko-KR" altLang="en-US" smtClean="0"/>
-              <a:t>2024-06-10</a:t>
+              <a:t>2024-06-05</a:t>
             </a:fld>
             <a:endParaRPr lang="ko-KR" altLang="en-US"/>
           </a:p>
@@ -25264,7 +25258,7 @@
           <a:p>
             <a:fld id="{0F78D9C4-20C1-4B15-A116-16DC77AD9A1E}" type="datetime1">
               <a:rPr lang="ko-KR" altLang="en-US" smtClean="0"/>
-              <a:t>2024-06-10</a:t>
+              <a:t>2024-06-05</a:t>
             </a:fld>
             <a:endParaRPr lang="ko-KR" altLang="en-US"/>
           </a:p>
@@ -25884,7 +25878,7 @@
           <a:p>
             <a:fld id="{0F78D9C4-20C1-4B15-A116-16DC77AD9A1E}" type="datetime1">
               <a:rPr lang="ko-KR" altLang="en-US" smtClean="0"/>
-              <a:t>2024-06-10</a:t>
+              <a:t>2024-06-05</a:t>
             </a:fld>
             <a:endParaRPr lang="ko-KR" altLang="en-US"/>
           </a:p>
@@ -29035,7 +29029,7 @@
           <a:p>
             <a:fld id="{0F78D9C4-20C1-4B15-A116-16DC77AD9A1E}" type="datetime1">
               <a:rPr lang="ko-KR" altLang="en-US" smtClean="0"/>
-              <a:t>2024-06-10</a:t>
+              <a:t>2024-06-05</a:t>
             </a:fld>
             <a:endParaRPr lang="ko-KR" altLang="en-US"/>
           </a:p>
@@ -32019,7 +32013,7 @@
           <a:p>
             <a:fld id="{0F78D9C4-20C1-4B15-A116-16DC77AD9A1E}" type="datetime1">
               <a:rPr lang="ko-KR" altLang="en-US" smtClean="0"/>
-              <a:t>2024-06-10</a:t>
+              <a:t>2024-06-05</a:t>
             </a:fld>
             <a:endParaRPr lang="ko-KR" altLang="en-US"/>
           </a:p>
@@ -32648,7 +32642,7 @@
           <a:p>
             <a:fld id="{0F78D9C4-20C1-4B15-A116-16DC77AD9A1E}" type="datetime1">
               <a:rPr lang="ko-KR" altLang="en-US" smtClean="0"/>
-              <a:t>2024-06-10</a:t>
+              <a:t>2024-06-05</a:t>
             </a:fld>
             <a:endParaRPr lang="ko-KR" altLang="en-US"/>
           </a:p>
@@ -33273,7 +33267,7 @@
           <a:p>
             <a:fld id="{0F78D9C4-20C1-4B15-A116-16DC77AD9A1E}" type="datetime1">
               <a:rPr lang="ko-KR" altLang="en-US" smtClean="0"/>
-              <a:t>2024-06-10</a:t>
+              <a:t>2024-06-05</a:t>
             </a:fld>
             <a:endParaRPr lang="ko-KR" altLang="en-US"/>
           </a:p>
@@ -33898,7 +33892,7 @@
           <a:p>
             <a:fld id="{0F78D9C4-20C1-4B15-A116-16DC77AD9A1E}" type="datetime1">
               <a:rPr lang="ko-KR" altLang="en-US" smtClean="0"/>
-              <a:t>2024-06-10</a:t>
+              <a:t>2024-06-05</a:t>
             </a:fld>
             <a:endParaRPr lang="ko-KR" altLang="en-US"/>
           </a:p>

</xml_diff>